<commit_message>
W04 D3: the seven concept calls as a drill set, an Applies line on every kept set, the lab's practice store moved off the kirana's numbers, the Kahoot naming each topic it tests, and both decks' minutes on the spine's envelope
Co-Authored-By: Claude Opus 5.5 <noreply@anthropic.com>
Claude-Session: https://claude.ai/code/session_01WYjHNveu7eWutxNQQBeHse
</commit_message>
<xml_diff>
--- a/content/W04/D3/slides/C2_W04_D03_half2_STUDENT.pptx
+++ b/content/W04/D3/slides/C2_W04_D03_half2_STUDENT.pptx
@@ -528,17 +528,22 @@
           </a:p>
           <a:p>
             <a:r>
-              <a:t>topic "Cross-sell and upsell reasoning; expected value in rupees". It opens the afternoon so the</a:t>
-            </a:r>
-          </a:p>
-          <a:p>
-            <a:r>
-              <a:t>morning carried four topics and this one gets fresh heads. Sharma Kirana's month sheet goes on</a:t>
-            </a:r>
-          </a:p>
-          <a:p>
-            <a:r>
-              <a:t>every table. Transition: who needs the answer.</a:t>
+              <a:t>topic "Cross-sell and upsell reasoning; expected value in rupees", 18 minutes with the second</a:t>
+            </a:r>
+          </a:p>
+          <a:p>
+            <a:r>
+              <a:t>concept drill inside them. It opens the afternoon so the morning carried four topics and this one</a:t>
+            </a:r>
+          </a:p>
+          <a:p>
+            <a:r>
+              <a:t>gets fresh heads. Sharma Kirana's month sheet goes on every table. Transition: who needs the</a:t>
+            </a:r>
+          </a:p>
+          <a:p>
+            <a:r>
+              <a:t>answer.</a:t>
             </a:r>
           </a:p>
         </p:txBody>
@@ -608,7 +613,7 @@
           <a:lstStyle/>
           <a:p>
             <a:r>
-              <a:t>LIVE, 4 minutes. The same four regions chapter 6 drew for the canteen: promote above the floor and</a:t>
+              <a:t>LIVE, 3 minutes. The same four regions chapter 6 drew for the canteen: promote above the floor and</a:t>
             </a:r>
           </a:p>
           <a:p>
@@ -1448,7 +1453,7 @@
           <a:lstStyle/>
           <a:p>
             <a:r>
-              <a:t>LIVE, 2 minutes. Define the two words with the shop's own items: cross-sell suggests an additional</a:t>
+              <a:t>LIVE, 1 minute 30 seconds. Define the two words with the shop's own items: cross-sell suggests an additional</a:t>
             </a:r>
           </a:p>
           <a:p>
@@ -1768,7 +1773,7 @@
           <a:lstStyle/>
           <a:p>
             <a:r>
-              <a:t>LIVE, 3 minutes. The misconception first: a promotion is worth the sales it touches. Groups vote</a:t>
+              <a:t>LIVE, 2 minutes. The misconception first: a promotion is worth the sales it touches. Groups vote</a:t>
             </a:r>
           </a:p>
           <a:p>
@@ -1853,7 +1858,7 @@
           <a:lstStyle/>
           <a:p>
             <a:r>
-              <a:t>LIVE, 5 minutes. Build the bridge left to right on the board, one bar at a time (StatQuest). The</a:t>
+              <a:t>LIVE, 3 minutes. Build the bridge left to right on the board, one bar at a time (StatQuest). The</a:t>
             </a:r>
           </a:p>
           <a:p>
@@ -1958,7 +1963,7 @@
           <a:lstStyle/>
           <a:p>
             <a:r>
-              <a:t>LIVE, 6 minutes. Read the top panel first: each rupee off costs Rs 168 a month, so the card earns</a:t>
+              <a:t>LIVE, 4 minutes. Read the top panel first: each rupee off costs Rs 168 a month, so the card earns</a:t>
             </a:r>
           </a:p>
           <a:p>
@@ -2063,22 +2068,42 @@
           <a:lstStyle/>
           <a:p>
             <a:r>
-              <a:t>LIVE, 1 minute. Fill the concept map's last box: all five topics are now on the board. Check</a:t>
-            </a:r>
-          </a:p>
-          <a:p>
-            <a:r>
-              <a:t>question before moving on: "A card reaches 2,000 bills, 5 percent add one pack at Rs 10 of margin,</a:t>
-            </a:r>
-          </a:p>
-          <a:p>
-            <a:r>
-              <a:t>and the cards cost Rs 600: what is it worth?" 100 packs, Rs 1,000 of margin, less Rs 600, so Rs 400.</a:t>
-            </a:r>
-          </a:p>
-          <a:p>
-            <a:r>
-              <a:t>Transition: chapter 10, the strip ranked and priced.</a:t>
+              <a:t>LIVE, 7 minutes. One minute for the rules: fill the concept map's last box, so all five topics are</a:t>
+            </a:r>
+          </a:p>
+          <a:p>
+            <a:r>
+              <a:t>now on the board. Check question before moving on: "A card reaches 2,000 bills, 5 percent add one</a:t>
+            </a:r>
+          </a:p>
+          <a:p>
+            <a:r>
+              <a:t>pack at Rs 10 of margin, and the cards cost Rs 600: what is it worth?" 100 packs, Rs 1,000 of</a:t>
+            </a:r>
+          </a:p>
+          <a:p>
+            <a:r>
+              <a:t>margin, less Rs 600, so Rs 400. Then the second concept drill, items 5 to 7 of</a:t>
+            </a:r>
+          </a:p>
+          <a:p>
+            <a:r>
+              <a:t>`exercises/unguided/C2_W04_D03_canteen_concepts_STUDENT.md`, on paper, 6 minutes: pairs from one</a:t>
+            </a:r>
+          </a:p>
+          <a:p>
+            <a:r>
+              <a:t>order, the floor on the canteen's month, and the kirana's forgotten cost line. Checkpoint: the room</a:t>
+            </a:r>
+          </a:p>
+          <a:p>
+            <a:r>
+              <a:t>says the expected-value line in the topic's words, margin on the purchases a card changes less</a:t>
+            </a:r>
+          </a:p>
+          <a:p>
+            <a:r>
+              <a:t>every rupee it hands back. Transition: chapter 10, the strip ranked and priced.</a:t>
             </a:r>
           </a:p>
         </p:txBody>
@@ -2223,12 +2248,12 @@
           <a:lstStyle/>
           <a:p>
             <a:r>
-              <a:t>LIVE, 1 minute. Read the four questions. Each is a morning topic used on the case: the floor and</a:t>
-            </a:r>
-          </a:p>
-          <a:p>
-            <a:r>
-              <a:t>the watch list from chapter 6, the rupees from chapter 9. Transition: the problem first.</a:t>
+              <a:t>LIVE, 30 seconds. Read the four questions. Each is a topic used on the case: the floor and the</a:t>
+            </a:r>
+          </a:p>
+          <a:p>
+            <a:r>
+              <a:t>watch list from chapter 6, the rupees from chapter 9. Transition: the problem first.</a:t>
             </a:r>
           </a:p>
         </p:txBody>
@@ -2298,17 +2323,27 @@
           <a:lstStyle/>
           <a:p>
             <a:r>
-              <a:t>LIVE, 3 minutes. Vote, argue, vote again (Brilliant: the problem before the explanation). The split</a:t>
-            </a:r>
-          </a:p>
-          <a:p>
-            <a:r>
-              <a:t>is usually b against c; a learner who drew chapter 6's canteen action map should call it at once.</a:t>
-            </a:r>
-          </a:p>
-          <a:p>
-            <a:r>
-              <a:t>Transition: every pair on one picture.</a:t>
+              <a:t>LIVE, 4 minutes. The prediction is sat as the unguided set</a:t>
+            </a:r>
+          </a:p>
+          <a:p>
+            <a:r>
+              <a:t>`exercises/unguided/C2_W04_D03_ch3_four_pairs_STUDENT.md` on paper, four letters posted in four</a:t>
+            </a:r>
+          </a:p>
+          <a:p>
+            <a:r>
+              <a:t>minutes; its first item is this slide's question under the stated rule (Brilliant: the problem</a:t>
+            </a:r>
+          </a:p>
+          <a:p>
+            <a:r>
+              <a:t>before the explanation). The split is usually b against c; a learner who drew chapter 6's canteen</a:t>
+            </a:r>
+          </a:p>
+          <a:p>
+            <a:r>
+              <a:t>action map should call it at once. Transition: every pair on one picture.</a:t>
             </a:r>
           </a:p>
         </p:txBody>

</xml_diff>

<commit_message>
W04 D3: both decks after the three cold reads
Half two credits the Rs 6.3 lakh to taking milk out, which the 1.5 bar does
by arithmetic, calls it gross before the adds that would have come anyway,
and leaves whether lift beats a count ranking without milk to a test; a slot
sits beside its own item; the watch list keeps chapter 6's reasons; the
Kahoot runs inside S73's minutes, so SECTION 10 holds 15 slides and the
close is S74.

Half one teaches lift's ceiling and what near one means in chapter 4, sets
the floor where luck stops carrying a lift past the bar, holds S37's numbers
until chapter 10, asks the reverse direction at S39, names Amazon's fix as a
difference in probabilities, and gives the tag key and the expected vote
splits.

Co-Authored-By: Claude Opus 5.5 <noreply@anthropic.com>
Claude-Session: https://claude.ai/code/session_01WYjHNveu7eWutxNQQBeHse
</commit_message>
<xml_diff>
--- a/content/W04/D3/slides/C2_W04_D03_half2_STUDENT.pptx
+++ b/content/W04/D3/slides/C2_W04_D03_half2_STUDENT.pptx
@@ -26,7 +26,6 @@
     <p:sldId id="274" r:id="rId26"/>
     <p:sldId id="275" r:id="rId27"/>
     <p:sldId id="276" r:id="rId28"/>
-    <p:sldId id="277" r:id="rId29"/>
   </p:sldIdLst>
   <p:sldSz cx="12191695" cy="6858000" type="screen4x3"/>
   <p:notesSz cx="6858000" cy="9144000"/>
@@ -613,22 +612,42 @@
           <a:lstStyle/>
           <a:p>
             <a:r>
-              <a:t>LIVE, 3 minutes. The same four regions chapter 6 drew for the canteen: promote above the floor and</a:t>
-            </a:r>
-          </a:p>
-          <a:p>
-            <a:r>
-              <a:t>well above one; watch, high lift below the floor; ignore, near one, where milk's pairs sit. The</a:t>
-            </a:r>
-          </a:p>
-          <a:p>
-            <a:r>
-              <a:t>floor is a decision: 0.5 percent admits more pairs on thinner ground, 2 percent fewer. Explorer:</a:t>
-            </a:r>
-          </a:p>
-          <a:p>
-            <a:r>
-              <a:t>scene W5, the floor slider counts the pairs that survive. Transition: the thin pair.</a:t>
+              <a:t>LIVE, 3 minutes. The fifth pair above the floor reads 1.09, near one. Run notebook 10's first</a:t>
+            </a:r>
+          </a:p>
+          <a:p>
+            <a:r>
+              <a:t>cells, which rank the pairs above the floor and list the strong ones below it, then hand out the pair cards: each group places its nine cards on chapter 6's</a:t>
+            </a:r>
+          </a:p>
+          <a:p>
+            <a:r>
+              <a:t>four regions and defends one placement in a sentence (the run sheet has the placements). Promote is</a:t>
+            </a:r>
+          </a:p>
+          <a:p>
+            <a:r>
+              <a:t>above the floor and over the bar; watch, over the bar below the floor; trap, near one above the</a:t>
+            </a:r>
+          </a:p>
+          <a:p>
+            <a:r>
+              <a:t>floor, where milk's pairs sit; ignore, near one below it. Each step right on the picture is ten</a:t>
+            </a:r>
+          </a:p>
+          <a:p>
+            <a:r>
+              <a:t>times more carts. The floor is a decision: 0.5 percent admits more pairs on thinner ground, 2</a:t>
+            </a:r>
+          </a:p>
+          <a:p>
+            <a:r>
+              <a:t>percent fewer. Explorer: scene W5, the floor slider counts the pairs that survive. Transition: the</a:t>
+            </a:r>
+          </a:p>
+          <a:p>
+            <a:r>
+              <a:t>thin pair.</a:t>
             </a:r>
           </a:p>
         </p:txBody>
@@ -703,7 +722,17 @@
           </a:p>
           <a:p>
             <a:r>
-              <a:t>earns a trial, never a slot. How long a trial must run to trust its answer is a sample-size</a:t>
+              <a:t>earns a trial, never a slot. Notebook 10 searches the band between 0.2 percent (80 carts) and the</a:t>
+            </a:r>
+          </a:p>
+          <a:p>
+            <a:r>
+              <a:t>floor, since thousands of pairs on a handful of carts read wild lifts by luck, as chapter 6's month</a:t>
+            </a:r>
+          </a:p>
+          <a:p>
+            <a:r>
+              <a:t>showed. How long a trial must run to trust its answer is a sample-size</a:t>
             </a:r>
           </a:p>
           <a:p>
@@ -778,7 +807,12 @@
           <a:lstStyle/>
           <a:p>
             <a:r>
-              <a:t>LIVE, 1 minute. Guess first, then build it. Transition: the cascade.</a:t>
+              <a:t>LIVE, 1 minute. Guess first, then build it; the split is usually b against c. Transition: the</a:t>
+            </a:r>
+          </a:p>
+          <a:p>
+            <a:r>
+              <a:t>cascade.</a:t>
             </a:r>
           </a:p>
         </p:txBody>
@@ -848,37 +882,67 @@
           <a:lstStyle/>
           <a:p>
             <a:r>
-              <a:t>LIVE, 2 minutes. Build it left to right on the board, each factor said with its source and its</a:t>
-            </a:r>
-          </a:p>
-          <a:p>
-            <a:r>
-              <a:t>range, as the kirana's 4 percent was. Margin is what Instamart keeps from a sale after the item's</a:t>
-            </a:r>
-          </a:p>
-          <a:p>
-            <a:r>
-              <a:t>cost: bread sells for Rs 45 and keeps Rs 6.70. Milk earns Rs 2 a pouch, so a milk slot earns even</a:t>
-            </a:r>
-          </a:p>
-          <a:p>
-            <a:r>
-              <a:t>less than the Rs 9 assumption gives it. Back to S64's thin pair, priced at its own margins, Rs</a:t>
-            </a:r>
-          </a:p>
-          <a:p>
-            <a:r>
-              <a:t>37.40 for sauce against Rs 2 for milk: on about 2,400 views a day in place of milk it earns about Rs</a:t>
-            </a:r>
-          </a:p>
-          <a:p>
-            <a:r>
-              <a:t>85,000 a month, which is why it earns a test and never a blind slot. Explorer: scene W4, the strip</a:t>
-            </a:r>
-          </a:p>
-          <a:p>
-            <a:r>
-              <a:t>simulator, rank by count against rank by lift. Transition: the number people get wrong.</a:t>
+              <a:t>LIVE, 2 minutes. The kirana's card at city scale: margin on the adds a slot makes, never its sales.</a:t>
+            </a:r>
+          </a:p>
+          <a:p>
+            <a:r>
+              <a:t>Build it left to right on the board, each factor said with its source and its range, as the</a:t>
+            </a:r>
+          </a:p>
+          <a:p>
+            <a:r>
+              <a:t>kirana's 4 percent was. Margin is what Instamart keeps from a sale after the item's cost: bread</a:t>
+            </a:r>
+          </a:p>
+          <a:p>
+            <a:r>
+              <a:t>sells for Rs 45 and keeps Rs 6.70. Every add is priced at the basket's average Rs 9, milk's too.</a:t>
+            </a:r>
+          </a:p>
+          <a:p>
+            <a:r>
+              <a:t>Two corrections pull opposite ways and both land inside the range: milk earns only Rs 2 a pouch,</a:t>
+            </a:r>
+          </a:p>
+          <a:p>
+            <a:r>
+              <a:t>which raises the gain, and the strip's own adds earned about Rs 7, which lowers it; with both,</a:t>
+            </a:r>
+          </a:p>
+          <a:p>
+            <a:r>
+              <a:t>about Rs 5.7 lakh. Whether a lift-ranked pair clicks better than any other suggestion is not in</a:t>
+            </a:r>
+          </a:p>
+          <a:p>
+            <a:r>
+              <a:t>this log: a test with a count-ranked arm, milk left out, against a lift-ranked arm measures it.</a:t>
+            </a:r>
+          </a:p>
+          <a:p>
+            <a:r>
+              <a:t>Back to S64's thin pair, priced at its own margins, Rs 37.40 for sauce against Rs 2 for milk: on</a:t>
+            </a:r>
+          </a:p>
+          <a:p>
+            <a:r>
+              <a:t>about 2,400 views a day in place of milk, 2,400 x 30 x (0.064 x 0.5 x Rs 37.40 less 0.012 x 0.5 x</a:t>
+            </a:r>
+          </a:p>
+          <a:p>
+            <a:r>
+              <a:t>Rs 2), it earns about Rs 85,000 a month, which is why it earns a test and never a blind slot.</a:t>
+            </a:r>
+          </a:p>
+          <a:p>
+            <a:r>
+              <a:t>Explorer: scene W4, the strip simulator, rank by count against rank by lift. Transition: the</a:t>
+            </a:r>
+          </a:p>
+          <a:p>
+            <a:r>
+              <a:t>number people get wrong.</a:t>
             </a:r>
           </a:p>
         </p:txBody>
@@ -953,12 +1017,12 @@
           </a:p>
           <a:p>
             <a:r>
-              <a:t>add falls by the discount. The doubts and the heavy tenth follow as two self-study slides, read in</a:t>
-            </a:r>
-          </a:p>
-          <a:p>
-            <a:r>
-              <a:t>the lab; the unguided work uses them. Transition: the doubts, for self-study, then the brief.</a:t>
+              <a:t>add falls by the discount. The doubts on D68 are read inside S70's group work, and the heavy tenth</a:t>
+            </a:r>
+          </a:p>
+          <a:p>
+            <a:r>
+              <a:t>on D69 is self-study. Transition: the doubts, then the brief.</a:t>
             </a:r>
           </a:p>
         </p:txBody>
@@ -1028,12 +1092,22 @@
           <a:lstStyle/>
           <a:p>
             <a:r>
-              <a:t>SELF-STUDY, 0 minutes live. Each doubt has its number in notebook 10. A check that comes back clean</a:t>
-            </a:r>
-          </a:p>
-          <a:p>
-            <a:r>
-              <a:t>is said in one line, as the time-of-day check does. In Hadapsar and Viman Nagar from 15 to 21</a:t>
+              <a:t>SELF-STUDY, 0 minutes live: groups read it inside S70's work. Each doubt has its number in notebook 10; the slot row is D54's</a:t>
+            </a:r>
+          </a:p>
+          <a:p>
+            <a:r>
+              <a:t>picture and notebook 10's slot split. A check that comes back clean is said in one line, as the</a:t>
+            </a:r>
+          </a:p>
+          <a:p>
+            <a:r>
+              <a:t>time-of-day check does. One more doubt sits under S66: whether a lift-ranked pair clicks better</a:t>
+            </a:r>
+          </a:p>
+          <a:p>
+            <a:r>
+              <a:t>than any other suggestion, which this log cannot say and a count-against-lift test measures. In Hadapsar and Viman Nagar from 15 to 21</a:t>
             </a:r>
           </a:p>
           <a:p>
@@ -1203,12 +1277,17 @@
           </a:p>
           <a:p>
             <a:r>
-              <a:t>"which number does the growth lead keep?". The doubts sit on D68 and in notebook 10's last cells.</a:t>
-            </a:r>
-          </a:p>
-          <a:p>
-            <a:r>
-              <a:t>The strip set's solutions file is released at the close. Transition: the objection each group must</a:t>
+              <a:t>"which number does the growth lead keep?". Groups read D68 for step 3 inside the ten minutes.</a:t>
+            </a:r>
+          </a:p>
+          <a:p>
+            <a:r>
+              <a:t>Checkpoint: every group hands in one strip with a rupee range. The strip set's solutions file is</a:t>
+            </a:r>
+          </a:p>
+          <a:p>
+            <a:r>
+              <a:t>released at the close. Transition: the objection each group must</a:t>
             </a:r>
           </a:p>
           <a:p>
@@ -1463,22 +1542,27 @@
           </a:p>
           <a:p>
             <a:r>
-              <a:t>upselling pages, checked 13 October 2026). Callback to chapter 3: tea and rusk sit in 150 of 1,000</a:t>
-            </a:r>
-          </a:p>
-          <a:p>
-            <a:r>
-              <a:t>bills where chance gives 120, so lift 1.25 on plenty of bills; the pair beats chance, and the</a:t>
-            </a:r>
-          </a:p>
-          <a:p>
-            <a:r>
-              <a:t>question is now what a card is worth. Instamart's strip suggests a different item beside the one</a:t>
-            </a:r>
-          </a:p>
-          <a:p>
-            <a:r>
-              <a:t>in the cart, which is cross-sell. Transition: the prediction.</a:t>
+              <a:t>upselling pages, checked 13 October 2026). Callback to chapters 3 and 6: tea and rusk sit in 150</a:t>
+            </a:r>
+          </a:p>
+          <a:p>
+            <a:r>
+              <a:t>of 1,000 bills where chance gives 120, lift 1.25 on plenty of bills, under the 1.5 bar, so chapter</a:t>
+            </a:r>
+          </a:p>
+          <a:p>
+            <a:r>
+              <a:t>6's sort would give the pair no slot of its own. A card is the shop's cheapest bet on a weak pull,</a:t>
+            </a:r>
+          </a:p>
+          <a:p>
+            <a:r>
+              <a:t>and this chapter prices what such a bet earns. Instamart's strip suggests a different item beside</a:t>
+            </a:r>
+          </a:p>
+          <a:p>
+            <a:r>
+              <a:t>the one in the cart, which is cross-sell. Transition: the prediction.</a:t>
             </a:r>
           </a:p>
         </p:txBody>
@@ -1548,12 +1632,32 @@
           <a:lstStyle/>
           <a:p>
             <a:r>
-              <a:t>LIVE, 1 minute. Read the line as it stands. Park any question about how long a watch-list trial</a:t>
-            </a:r>
-          </a:p>
-          <a:p>
-            <a:r>
-              <a:t>must run for the faculty session (tentative). Transition: the Kahoot.</a:t>
+              <a:t>LIVE, 8 minutes: 1 for the line, read as it stands, and 7 for the Kahoot pack from the kahoot</a:t>
+            </a:r>
+          </a:p>
+          <a:p>
+            <a:r>
+              <a:t>folder, ungraded, eight items: the three counts and a lift from three counts; a popular partner and</a:t>
+            </a:r>
+          </a:p>
+          <a:p>
+            <a:r>
+              <a:t>the strip's blended click-through; a strong thin pair, what a promotion is worth and one cart's</a:t>
+            </a:r>
+          </a:p>
+          <a:p>
+            <a:r>
+              <a:t>pairs; Tuesday's four moves. Re-teach in one line any item most of the room misses. Park any</a:t>
+            </a:r>
+          </a:p>
+          <a:p>
+            <a:r>
+              <a:t>question about how long a watch-list trial must run for the faculty session (tentative).</a:t>
+            </a:r>
+          </a:p>
+          <a:p>
+            <a:r>
+              <a:t>Transition: the close.</a:t>
             </a:r>
           </a:p>
         </p:txBody>
@@ -1623,81 +1727,6 @@
           <a:lstStyle/>
           <a:p>
             <a:r>
-              <a:t>LIVE, 7 minutes. Run the Kahoot pack from the kahoot folder; it is ungraded. Re-teach in one line</a:t>
-            </a:r>
-          </a:p>
-          <a:p>
-            <a:r>
-              <a:t>any item most of the room misses. Transition: the close.</a:t>
-            </a:r>
-          </a:p>
-        </p:txBody>
-      </p:sp>
-      <p:sp>
-        <p:nvSpPr>
-          <p:cNvPr id="4" name="Slide Number Placeholder 3"/>
-          <p:cNvSpPr>
-            <a:spLocks noGrp="1"/>
-          </p:cNvSpPr>
-          <p:nvPr>
-            <p:ph type="sldNum" idx="5" sz="quarter"/>
-          </p:nvPr>
-        </p:nvSpPr>
-        <p:spPr/>
-      </p:sp>
-    </p:spTree>
-  </p:cSld>
-  <p:clrMapOvr>
-    <a:masterClrMapping/>
-  </p:clrMapOvr>
-</p:notes>
-</file>
-
-<file path=ppt/notesSlides/notesSlide22.xml><?xml version="1.0" encoding="utf-8"?>
-<p:notes xmlns:a="http://schemas.openxmlformats.org/drawingml/2006/main" xmlns:p="http://schemas.openxmlformats.org/presentationml/2006/main" xmlns:r="http://schemas.openxmlformats.org/officeDocument/2006/relationships">
-  <p:cSld>
-    <p:spTree>
-      <p:nvGrpSpPr>
-        <p:cNvPr id="1" name=""/>
-        <p:cNvGrpSpPr/>
-        <p:nvPr/>
-      </p:nvGrpSpPr>
-      <p:grpSpPr>
-        <a:xfrm>
-          <a:off x="0" y="0"/>
-          <a:ext cx="0" cy="0"/>
-          <a:chOff x="0" y="0"/>
-          <a:chExt cx="0" cy="0"/>
-        </a:xfrm>
-      </p:grpSpPr>
-      <p:sp>
-        <p:nvSpPr>
-          <p:cNvPr id="2" name="Slide Image Placeholder 1"/>
-          <p:cNvSpPr>
-            <a:spLocks noGrp="1"/>
-          </p:cNvSpPr>
-          <p:nvPr>
-            <p:ph type="sldImg" idx="2"/>
-          </p:nvPr>
-        </p:nvSpPr>
-        <p:spPr/>
-      </p:sp>
-      <p:sp>
-        <p:nvSpPr>
-          <p:cNvPr id="3" name="Notes Placeholder 2"/>
-          <p:cNvSpPr>
-            <a:spLocks noGrp="1"/>
-          </p:cNvSpPr>
-          <p:nvPr>
-            <p:ph type="body" idx="3" sz="quarter"/>
-          </p:nvPr>
-        </p:nvSpPr>
-        <p:spPr/>
-        <p:txBody>
-          <a:bodyPr/>
-          <a:lstStyle/>
-          <a:p>
-            <a:r>
               <a:t>LIVE, 2 minutes. Ask two learners to say the sentence without notes. The lab after class runs the</a:t>
             </a:r>
           </a:p>
@@ -1963,12 +1992,17 @@
           <a:lstStyle/>
           <a:p>
             <a:r>
-              <a:t>LIVE, 4 minutes. Read the top panel first: each rupee off costs Rs 168 a month, so the card earns</a:t>
-            </a:r>
-          </a:p>
-          <a:p>
-            <a:r>
-              <a:t>nothing at about Rs 1.17 off and loses Rs 140 at Rs 2. Then the bottom panel: at 2 percent the card</a:t>
+              <a:t>LIVE, 4 minutes. Read the top panel first: each rupee off costs Rs 168 a month, so at the same 4</a:t>
+            </a:r>
+          </a:p>
+          <a:p>
+            <a:r>
+              <a:t>percent response the card earns nothing at about Rs 1.17 off and loses Rs 140 at Rs 2; a bigger</a:t>
+            </a:r>
+          </a:p>
+          <a:p>
+            <a:r>
+              <a:t>discount may draw more buyers, which only a trial of the card would show. Then the bottom panel: at 2 percent the card</a:t>
             </a:r>
           </a:p>
           <a:p>
@@ -2328,17 +2362,17 @@
           </a:p>
           <a:p>
             <a:r>
-              <a:t>`exercises/unguided/C2_W04_D03_ch3_four_pairs_STUDENT.md` on paper, four letters posted in four</a:t>
-            </a:r>
-          </a:p>
-          <a:p>
-            <a:r>
-              <a:t>minutes; its first item is this slide's question under the stated rule (Brilliant: the problem</a:t>
-            </a:r>
-          </a:p>
-          <a:p>
-            <a:r>
-              <a:t>before the explanation). The split is usually b against c; a learner who drew chapter 6's canteen</a:t>
+              <a:t>`exercises/unguided/C2_W04_D03_ch10_four_pairs_STUDENT.md` on paper, four letters posted in four</a:t>
+            </a:r>
+          </a:p>
+          <a:p>
+            <a:r>
+              <a:t>minutes; its first item asks which pairs clear the stated rule, and this slide asks which of them</a:t>
+            </a:r>
+          </a:p>
+          <a:p>
+            <a:r>
+              <a:t>ranks first (Brilliant: the problem before the explanation). The split is usually b against c; a learner who drew chapter 6's canteen</a:t>
             </a:r>
           </a:p>
           <a:p>
@@ -5817,7 +5851,7 @@
                 </a:solidFill>
                 <a:latin typeface="Calibri"/>
               </a:rPr>
-              <a:t>1 / 22</a:t>
+              <a:t>1 / 21</a:t>
             </a:r>
           </a:p>
         </p:txBody>
@@ -6151,7 +6185,7 @@
                 </a:solidFill>
                 <a:latin typeface="Calibri"/>
               </a:rPr>
-              <a:t>Above a floor of 1 percent of carts (400 carts), 246 pairs qualify and four reach lift 1.5 or more: chips and cold drink 3.39, coriander and green chillies 3.00, bread and butter 2.21, onions and tomatoes 1.70. The fifth reads 1.09. The strip has three slots, so onions and tomatoes waits as the first replacement. Each step right on the picture is ten times more carts.</a:t>
+              <a:t>Above a floor of 1 percent of carts (400 carts), 246 pairs qualify; four reach lift 1.5: chips and cold drink 3.39, coriander and green chillies 3.00, bread and butter 2.21, onions and tomatoes 1.70. Each fills a slot beside its own item, and elsewhere the strip falls back to the curated list it ran before 7 September. No partner of milk can pass 1 / 0.71 = 1.41.</a:t>
             </a:r>
           </a:p>
         </p:txBody>
@@ -6344,7 +6378,7 @@
                 </a:solidFill>
                 <a:latin typeface="Calibri"/>
               </a:rPr>
-              <a:t>S63  ·  10 / 22</a:t>
+              <a:t>S63  ·  10 / 21</a:t>
             </a:r>
           </a:p>
         </p:txBody>
@@ -6624,7 +6658,7 @@
                 </a:solidFill>
                 <a:latin typeface="Calibri"/>
               </a:rPr>
-              <a:t>Ice cream and chocolate sauce read lift 4.60, the strongest pair between 0.2 percent (80 carts, too few even to trial below it) and the 1 percent floor. The pair is real, 100 carts where chance gives 22, but the strip suggests it only beside ice cream, which is in 4 percent of carts: about 2,400 of the strip's 60,000 views a day, if views follow carts, and 100 carts cannot say how shoppers will click it there. It goes on the watch list: in two zones, a random half of shoppers see it beside ice cream, and it takes the slot only if their ice-cream carts buy sauce more often than the other half's, by a gap set before the trial, with margin per shopper as the guardrail.</a:t>
+              <a:t>Ice cream and chocolate sauce read lift 4.60 on 100 carts, the strongest pair below the 1 percent floor with enough carts to trial. The pair is real, 100 carts where chance gives 22, but the strip suggests it only beside ice cream, which is in 4 percent of carts: about 2,400 of the strip's 60,000 views a day, if views follow carts, and 100 carts cannot say how shoppers will click it there. It goes on the watch list: in two zones, a random half of shoppers see it beside ice cream, and it takes the slot only if their ice-cream carts buy sauce more often than the other half's, by a gap set before the trial, with margin per shopper as the guardrail, a number that must not fall while the trial runs.</a:t>
             </a:r>
           </a:p>
         </p:txBody>
@@ -6817,7 +6851,7 @@
                 </a:solidFill>
                 <a:latin typeface="Calibri"/>
               </a:rPr>
-              <a:t>S64  ·  11 / 22</a:t>
+              <a:t>S64  ·  11 / 21</a:t>
             </a:r>
           </a:p>
         </p:txBody>
@@ -7023,7 +7057,7 @@
                 </a:solidFill>
                 <a:latin typeface="Georgia"/>
               </a:rPr>
-              <a:t>What does re-ranking recover in a month?</a:t>
+              <a:t>What does taking milk out recover in a month?</a:t>
             </a:r>
           </a:p>
         </p:txBody>
@@ -7058,7 +7092,7 @@
                 </a:solidFill>
                 <a:latin typeface="Calibri"/>
               </a:rPr>
-              <a:t>Milk holds half the slot impressions at 1.2 percent. Moving them to pairs that click at 6.4 recovers how much?</a:t>
+              <a:t>Milk holds half the slot impressions at 1.2 percent. Given to suggestions that click at 6.4, how much does a month recover?</a:t>
             </a:r>
           </a:p>
         </p:txBody>
@@ -7973,7 +8007,46 @@
       </p:sp>
       <p:sp>
         <p:nvSpPr>
-          <p:cNvPr id="33" name="Oval 32"/>
+          <p:cNvPr id="33" name="TextBox 32"/>
+          <p:cNvSpPr txBox="1"/>
+          <p:nvPr/>
+        </p:nvSpPr>
+        <p:spPr>
+          <a:xfrm>
+            <a:off x="530352" y="4104132"/>
+            <a:ext cx="11130991" cy="495807"/>
+          </a:xfrm>
+          <a:prstGeom prst="rect">
+            <a:avLst/>
+          </a:prstGeom>
+          <a:noFill/>
+        </p:spPr>
+        <p:txBody>
+          <a:bodyPr wrap="square" anchor="t" lIns="0" rIns="0" tIns="0" bIns="0">
+            <a:spAutoFit/>
+          </a:bodyPr>
+          <a:lstStyle/>
+          <a:p>
+            <a:pPr>
+              <a:spcAft>
+                <a:spcPts val="800"/>
+              </a:spcAft>
+            </a:pPr>
+            <a:r>
+              <a:rPr sz="1600" b="0" i="0">
+                <a:solidFill>
+                  <a:srgbClr val="1A1440"/>
+                </a:solidFill>
+                <a:latin typeface="Calibri"/>
+              </a:rPr>
+              <a:t>The inputs: 60,000 views a slot a day, 0.5 adds per click, Rs 9 of margin an add, 30 days.</a:t>
+            </a:r>
+          </a:p>
+        </p:txBody>
+      </p:sp>
+      <p:sp>
+        <p:nvSpPr>
+          <p:cNvPr id="34" name="Oval 33"/>
           <p:cNvSpPr/>
           <p:nvPr/>
         </p:nvSpPr>
@@ -8017,7 +8090,7 @@
       </p:sp>
       <p:sp>
         <p:nvSpPr>
-          <p:cNvPr id="34" name="TextBox 33"/>
+          <p:cNvPr id="35" name="TextBox 34"/>
           <p:cNvSpPr txBox="1"/>
           <p:nvPr/>
         </p:nvSpPr>
@@ -8052,7 +8125,7 @@
       </p:sp>
       <p:sp>
         <p:nvSpPr>
-          <p:cNvPr id="35" name="Oval 34"/>
+          <p:cNvPr id="36" name="Oval 35"/>
           <p:cNvSpPr/>
           <p:nvPr/>
         </p:nvSpPr>
@@ -8096,7 +8169,7 @@
       </p:sp>
       <p:sp>
         <p:nvSpPr>
-          <p:cNvPr id="36" name="TextBox 35"/>
+          <p:cNvPr id="37" name="TextBox 36"/>
           <p:cNvSpPr txBox="1"/>
           <p:nvPr/>
         </p:nvSpPr>
@@ -8131,7 +8204,7 @@
       </p:sp>
       <p:sp>
         <p:nvSpPr>
-          <p:cNvPr id="37" name="TextBox 36"/>
+          <p:cNvPr id="38" name="TextBox 37"/>
           <p:cNvSpPr txBox="1"/>
           <p:nvPr/>
         </p:nvSpPr>
@@ -8159,7 +8232,7 @@
                 </a:solidFill>
                 <a:latin typeface="Calibri"/>
               </a:rPr>
-              <a:t>S65  ·  12 / 22</a:t>
+              <a:t>S65  ·  12 / 21</a:t>
             </a:r>
           </a:p>
         </p:txBody>
@@ -8365,7 +8438,7 @@
                 </a:solidFill>
                 <a:latin typeface="Georgia"/>
               </a:rPr>
-              <a:t>Answer: c, about Rs 6.3 lakh a month</a:t>
+              <a:t>Answer: c, about Rs 6.3 lakh a month, gross</a:t>
             </a:r>
           </a:p>
         </p:txBody>
@@ -8400,7 +8473,7 @@
                 </a:solidFill>
                 <a:latin typeface="Calibri"/>
               </a:rPr>
-              <a:t>How do chapter 9's rupees price a slot, and what does a month recover?</a:t>
+              <a:t>How do chapter 9's rupees price a slot, and where does the month's money come from?</a:t>
             </a:r>
           </a:p>
         </p:txBody>
@@ -8421,8 +8494,8 @@
         </p:blipFill>
         <p:spPr>
           <a:xfrm>
-            <a:off x="1303292" y="1664208"/>
-            <a:ext cx="9585109" cy="3077464"/>
+            <a:off x="1679861" y="1664208"/>
+            <a:ext cx="8831971" cy="2835656"/>
           </a:xfrm>
           <a:prstGeom prst="rect">
             <a:avLst/>
@@ -8437,7 +8510,7 @@
         </p:nvSpPr>
         <p:spPr>
           <a:xfrm>
-            <a:off x="530352" y="4778248"/>
+            <a:off x="530352" y="4536440"/>
             <a:ext cx="11130991" cy="316992"/>
           </a:xfrm>
           <a:prstGeom prst="rect">
@@ -8472,8 +8545,8 @@
         </p:nvSpPr>
         <p:spPr>
           <a:xfrm>
-            <a:off x="530352" y="5104384"/>
-            <a:ext cx="11130991" cy="1095247"/>
+            <a:off x="530352" y="4862576"/>
+            <a:ext cx="11130991" cy="1337056"/>
           </a:xfrm>
           <a:prstGeom prst="rect">
             <a:avLst/>
@@ -8493,7 +8566,7 @@
                 </a:solidFill>
                 <a:latin typeface="Calibri"/>
               </a:rPr>
-              <a:t>The kirana's card at city scale: margin on the adds a slot makes, never its sales. A slot's day is 60,000 views (strip_log) x click-through x 0.5 adds per click (strip_log, range 0.4 to 0.6) x Rs 9 margin an add (the average cart_items line, range Rs 7 to Rs 11), with the promoted pairs assumed to click at the 6.4 percent the rest drew. Milk holds 1.5 slots' worth: Rs 4.2 lakh x 1.5 = Rs 6.3 lakh a month, Rs 3.9 lakh at 0.4 x Rs 7 and Rs 9.3 lakh at 0.6 x Rs 11.</a:t>
+              <a:t>A slot's day is 60,000 views (strip_log) x click-through x 0.5 adds per click (strip_log, range 0.4 to 0.6) x Rs 9 margin an add (the average cart_items line, range Rs 7 to Rs 11). Milk holds 1.5 slots' worth: Rs 4.2 lakh x 1.5 = Rs 6.3 lakh a month, Rs 3.9 lakh to Rs 9.3 lakh across the ranges, before the adds that would have come anyway. The 6.4 percent is what any suggestion but milk drew: in slot 1, cold drink beside chips (lift 3.39) drew 8.2 percent and bread beside eggs (0.99) 8.4, so the money comes from taking milk out.</a:t>
             </a:r>
           </a:p>
         </p:txBody>
@@ -8686,7 +8759,7 @@
                 </a:solidFill>
                 <a:latin typeface="Calibri"/>
               </a:rPr>
-              <a:t>S66  ·  13 / 22</a:t>
+              <a:t>S66  ·  13 / 21</a:t>
             </a:r>
           </a:p>
         </p:txBody>
@@ -8892,7 +8965,7 @@
                 </a:solidFill>
                 <a:latin typeface="Georgia"/>
               </a:rPr>
-              <a:t>The trap: Rs 80,197 of sales is not the gain</a:t>
+              <a:t>The trap: about Rs 80,200 of sales is not the gain</a:t>
             </a:r>
           </a:p>
         </p:txBody>
@@ -8927,7 +9000,7 @@
                 </a:solidFill>
                 <a:latin typeface="Calibri"/>
               </a:rPr>
-              <a:t>Which number would overstate the slot four times over?</a:t>
+              <a:t>Which number would overstate the slot four and a half times over?</a:t>
             </a:r>
           </a:p>
         </p:txBody>
@@ -8966,7 +9039,7 @@
                 </a:solidFill>
                 <a:latin typeface="Calibri"/>
               </a:rPr>
-              <a:t>The plausible wrong answer books sales, the kirana's Rs 5,040 at city scale: a slot at 6.4 percent makes 1,920 adds a day, each selling for about Rs 41.77, so Rs 80,197 a day of "strip revenue". The growth lead keeps the margin, Rs 17,280. If the strip ever adds a bundle discount, the discount is margin handed back, on adds that might have happened anyway, as on the kirana's 150 bills that held both before the card. Swiggy's shareholder letter for April to June 2025 describes Maxxsaver, a discount unlocked once a basket passes a set size, as margin returned to the user: the cost line a rupee case must carry (checked 12 October 2026).</a:t>
+              <a:t>The plausible wrong answer books sales, the kirana's Rs 5,040 at city scale: a slot at 6.4 percent makes 1,920 adds a day, each selling for Rs 41.77 on average, so about Rs 80,200 a day of "strip revenue". The growth lead keeps the margin, Rs 17,280. If the strip ever adds a bundle discount, the discount is margin handed back, on adds that might have happened anyway, as on the kirana's 150 bills that held both before the card. Swiggy's shareholder letter for April to June 2025 describes Maxxsaver, a discount unlocked once a basket passes a set size, as margin returned to the user: the cost line a rupee case must carry (checked 12 October 2026).</a:t>
             </a:r>
           </a:p>
         </p:txBody>
@@ -9159,7 +9232,7 @@
                 </a:solidFill>
                 <a:latin typeface="Calibri"/>
               </a:rPr>
-              <a:t>S67  ·  14 / 22</a:t>
+              <a:t>S67  ·  14 / 21</a:t>
             </a:r>
           </a:p>
         </p:txBody>
@@ -9586,7 +9659,7 @@
                           </a:solidFill>
                           <a:latin typeface="Calibri"/>
                         </a:rPr>
-                        <a:t>A holdout: a share of shoppers kept on the old strip, compared with the rest</a:t>
+                        <a:t>A holdout: a random share of shoppers who see no strip, compared with the rest</a:t>
                       </a:r>
                     </a:p>
                   </a:txBody>
@@ -10151,7 +10224,7 @@
                 </a:solidFill>
                 <a:latin typeface="Calibri"/>
               </a:rPr>
-              <a:t>D68  ·  15 / 22</a:t>
+              <a:t>D68  ·  15 / 21</a:t>
             </a:r>
           </a:p>
         </p:txBody>
@@ -10468,8 +10541,8 @@
         </p:blipFill>
         <p:spPr>
           <a:xfrm>
-            <a:off x="1551914" y="1664208"/>
-            <a:ext cx="9087866" cy="2662936"/>
+            <a:off x="1257191" y="1664208"/>
+            <a:ext cx="9677312" cy="2835656"/>
           </a:xfrm>
           <a:prstGeom prst="rect">
             <a:avLst/>
@@ -10484,7 +10557,7 @@
         </p:nvSpPr>
         <p:spPr>
           <a:xfrm>
-            <a:off x="530352" y="4363720"/>
+            <a:off x="530352" y="4536440"/>
             <a:ext cx="11130991" cy="316992"/>
           </a:xfrm>
           <a:prstGeom prst="rect">
@@ -10519,28 +10592,28 @@
         </p:nvSpPr>
         <p:spPr>
           <a:xfrm>
-            <a:off x="530352" y="4689856"/>
-            <a:ext cx="11130991" cy="1509775"/>
-          </a:xfrm>
-          <a:prstGeom prst="rect">
-            <a:avLst/>
-          </a:prstGeom>
-          <a:noFill/>
-        </p:spPr>
-        <p:txBody>
-          <a:bodyPr wrap="square" anchor="t" lIns="0" rIns="0" tIns="0" bIns="0">
-            <a:spAutoFit/>
-          </a:bodyPr>
-          <a:lstStyle/>
-          <a:p>
-            <a:r>
-              <a:rPr sz="1600" b="0" i="0">
+            <a:off x="530352" y="4862576"/>
+            <a:ext cx="11130991" cy="1337056"/>
+          </a:xfrm>
+          <a:prstGeom prst="rect">
+            <a:avLst/>
+          </a:prstGeom>
+          <a:noFill/>
+        </p:spPr>
+        <p:txBody>
+          <a:bodyPr wrap="square" anchor="t" lIns="0" rIns="0" tIns="0" bIns="0">
+            <a:spAutoFit/>
+          </a:bodyPr>
+          <a:lstStyle/>
+          <a:p>
+            <a:r>
+              <a:rPr sz="1400" b="0" i="0">
                 <a:solidFill>
                   <a:srgbClr val="1A1440"/>
                 </a:solidFill>
                 <a:latin typeface="Calibri"/>
               </a:rPr>
-              <a:t>The top tenth of customers place 38 percent of the carts and 73 percent of the carts holding both chips and a cold drink. Counting every customer once gives each cart a weight of one over its customer's number of carts, so a shopper with 4 carts counts each as 0.25. Counted that way, the pair's lift falls from 3.39 to 2.56 and still beats chance; bread and milk stays at 1.04. The pair keeps its slot, and the growth lead says the smaller number.</a:t>
+              <a:t>The top tenth of customers place 38 percent of the carts and 73 percent of the carts holding both chips and a cold drink. Counting every customer once gives each cart a weight of one over its customer's number of carts, so a shopper with 4 carts counts each as 0.25; lift is then the weighted share of carts holding both over the weighted shares holding each, multiplied. Counted that way, the pair's lift falls from 3.39 to 2.56 and still beats chance; bread and milk stays at 1.04. The pair keeps its slot, and the growth lead says the smaller number.</a:t>
             </a:r>
           </a:p>
         </p:txBody>
@@ -10733,7 +10806,7 @@
                 </a:solidFill>
                 <a:latin typeface="Calibri"/>
               </a:rPr>
-              <a:t>D69  ·  16 / 22</a:t>
+              <a:t>D69  ·  16 / 21</a:t>
             </a:r>
           </a:p>
         </p:txBody>
@@ -10939,7 +11012,7 @@
                 </a:solidFill>
                 <a:latin typeface="Georgia"/>
               </a:rPr>
-              <a:t>Ship one strip in 15 minutes, priced and defended</a:t>
+              <a:t>Ship one strip, priced and defended</a:t>
             </a:r>
           </a:p>
         </p:txBody>
@@ -12120,7 +12193,7 @@
                 </a:solidFill>
                 <a:latin typeface="Calibri"/>
               </a:rPr>
-              <a:t>S70  ·  17 / 22</a:t>
+              <a:t>S70  ·  17 / 21</a:t>
             </a:r>
           </a:p>
         </p:txBody>
@@ -12375,7 +12448,7 @@
         <p:spPr>
           <a:xfrm>
             <a:off x="530352" y="1956816"/>
-            <a:ext cx="2645587" cy="2385568"/>
+            <a:ext cx="2645587" cy="2534412"/>
           </a:xfrm>
           <a:prstGeom prst="roundRect">
             <a:avLst>
@@ -12602,7 +12675,7 @@
         <p:spPr>
           <a:xfrm>
             <a:off x="3358819" y="1956816"/>
-            <a:ext cx="2645587" cy="2385568"/>
+            <a:ext cx="2645587" cy="2534412"/>
           </a:xfrm>
           <a:prstGeom prst="roundRect">
             <a:avLst>
@@ -12815,7 +12888,7 @@
                 </a:solidFill>
                 <a:latin typeface="Calibri"/>
               </a:rPr>
-              <a:t>Milk slots click at 1.2 percent against 6.4; lift with every common item sits near one.</a:t>
+              <a:t>Milk slots click at 1.2 percent against 6.4, and no item's lift with milk can pass 1.41.</a:t>
             </a:r>
           </a:p>
         </p:txBody>
@@ -12829,7 +12902,7 @@
         <p:spPr>
           <a:xfrm>
             <a:off x="6187287" y="1956816"/>
-            <a:ext cx="2645587" cy="2385568"/>
+            <a:ext cx="2645587" cy="2534412"/>
           </a:xfrm>
           <a:prstGeom prst="roundRect">
             <a:avLst>
@@ -13056,7 +13129,7 @@
         <p:spPr>
           <a:xfrm>
             <a:off x="9015755" y="1956816"/>
-            <a:ext cx="2645587" cy="2385568"/>
+            <a:ext cx="2645587" cy="2534412"/>
           </a:xfrm>
           <a:prstGeom prst="roundRect">
             <a:avLst>
@@ -13219,7 +13292,7 @@
         <p:spPr>
           <a:xfrm>
             <a:off x="9216923" y="2962656"/>
-            <a:ext cx="2243251" cy="498856"/>
+            <a:ext cx="2243251" cy="267716"/>
           </a:xfrm>
           <a:prstGeom prst="rect">
             <a:avLst/>
@@ -13240,7 +13313,7 @@
                 </a:solidFill>
                 <a:latin typeface="Calibri"/>
               </a:rPr>
-              <a:t>If milk clicked like the rest</a:t>
+              <a:t>If milk earned its slot</a:t>
             </a:r>
           </a:p>
         </p:txBody>
@@ -13253,8 +13326,8 @@
         </p:nvSpPr>
         <p:spPr>
           <a:xfrm>
-            <a:off x="9216923" y="3534664"/>
-            <a:ext cx="2243251" cy="581406"/>
+            <a:off x="9216923" y="3303524"/>
+            <a:ext cx="2243251" cy="944626"/>
           </a:xfrm>
           <a:prstGeom prst="rect">
             <a:avLst/>
@@ -13275,7 +13348,7 @@
                 </a:solidFill>
                 <a:latin typeface="Calibri"/>
               </a:rPr>
-              <a:t>A two-zone test where milk slots matched 6.4 percent would put milk back.</a:t>
+              <a:t>A test with shoppers randomised, in which a milk slot earned as much margin per shopper as the suggestion it replaced, would put milk back.</a:t>
             </a:r>
           </a:p>
         </p:txBody>
@@ -13468,7 +13541,7 @@
                 </a:solidFill>
                 <a:latin typeface="Calibri"/>
               </a:rPr>
-              <a:t>S71  ·  18 / 22</a:t>
+              <a:t>S71  ·  18 / 21</a:t>
             </a:r>
           </a:p>
         </p:txBody>
@@ -13723,7 +13796,7 @@
         <p:spPr>
           <a:xfrm>
             <a:off x="530352" y="1956816"/>
-            <a:ext cx="3588410" cy="2765552"/>
+            <a:ext cx="3588410" cy="2955544"/>
           </a:xfrm>
           <a:prstGeom prst="roundRect">
             <a:avLst>
@@ -13950,7 +14023,7 @@
         <p:spPr>
           <a:xfrm>
             <a:off x="4301642" y="1956816"/>
-            <a:ext cx="3588410" cy="2765552"/>
+            <a:ext cx="3588410" cy="2955544"/>
           </a:xfrm>
           <a:prstGeom prst="roundRect">
             <a:avLst>
@@ -14148,7 +14221,7 @@
         <p:spPr>
           <a:xfrm>
             <a:off x="4502810" y="3534664"/>
-            <a:ext cx="3186074" cy="944626"/>
+            <a:ext cx="3186074" cy="1126236"/>
           </a:xfrm>
           <a:prstGeom prst="rect">
             <a:avLst/>
@@ -14169,7 +14242,7 @@
                 </a:solidFill>
                 <a:latin typeface="Calibri"/>
               </a:rPr>
-              <a:t>"Bread to milk reads confidence 0.74, but milk is in 71 percent of carts anyway, so lift is 1.04. Chips and cold drink read 0.42 and lift 3.39. I rank by lift above a support floor."</a:t>
+              <a:t>"Bread to milk reads confidence 0.74, but milk is in 71 percent of carts anyway, so lift is 1.04. Chips and cold drink read 0.42 and lift 3.39. I rank by lift above a floor of 1 percent of September's carts, 400 carts, and slot a pair only at 1.5 or more."</a:t>
             </a:r>
           </a:p>
         </p:txBody>
@@ -14183,7 +14256,7 @@
         <p:spPr>
           <a:xfrm>
             <a:off x="8072932" y="1956816"/>
-            <a:ext cx="3588410" cy="2765552"/>
+            <a:ext cx="3588410" cy="2955544"/>
           </a:xfrm>
           <a:prstGeom prst="roundRect">
             <a:avLst>
@@ -14589,7 +14662,7 @@
                 </a:solidFill>
                 <a:latin typeface="Calibri"/>
               </a:rPr>
-              <a:t>S72  ·  19 / 22</a:t>
+              <a:t>S72  ·  19 / 21</a:t>
             </a:r>
           </a:p>
         </p:txBody>
@@ -16153,7 +16226,7 @@
                 </a:solidFill>
                 <a:latin typeface="Calibri"/>
               </a:rPr>
-              <a:t>S56  ·  2 / 22</a:t>
+              <a:t>S56  ·  2 / 21</a:t>
             </a:r>
           </a:p>
         </p:txBody>
@@ -16394,7 +16467,7 @@
                 </a:solidFill>
                 <a:latin typeface="Calibri"/>
               </a:rPr>
-              <a:t>What does the IITGN faculty session (tentative) pick up from the morning?</a:t>
+              <a:t>What does the IITGN faculty session (tentative) pick up from today?</a:t>
             </a:r>
           </a:p>
         </p:txBody>
@@ -16706,7 +16779,7 @@
                 </a:solidFill>
                 <a:latin typeface="Calibri"/>
               </a:rPr>
-              <a:t>S73  ·  20 / 22</a:t>
+              <a:t>S73  ·  20 / 21</a:t>
             </a:r>
           </a:p>
         </p:txBody>
@@ -16912,7 +16985,7 @@
                 </a:solidFill>
                 <a:latin typeface="Georgia"/>
               </a:rPr>
-              <a:t>Eight quick questions, one with a minute to compute</a:t>
+              <a:t>The sentence for Friday, and Thursday's question</a:t>
             </a:r>
           </a:p>
         </p:txBody>
@@ -16947,1296 +17020,6 @@
                 </a:solidFill>
                 <a:latin typeface="Calibri"/>
               </a:rPr>
-              <a:t>Can the room make the day's calls at speed?</a:t>
-            </a:r>
-          </a:p>
-        </p:txBody>
-      </p:sp>
-      <p:sp>
-        <p:nvSpPr>
-          <p:cNvPr id="9" name="Rectangle 8"/>
-          <p:cNvSpPr/>
-          <p:nvPr/>
-        </p:nvSpPr>
-        <p:spPr>
-          <a:xfrm>
-            <a:off x="1853145" y="2523744"/>
-            <a:ext cx="8485403" cy="18288"/>
-          </a:xfrm>
-          <a:prstGeom prst="rect">
-            <a:avLst/>
-          </a:prstGeom>
-          <a:solidFill>
-            <a:srgbClr val="CFC9EE"/>
-          </a:solidFill>
-          <a:ln>
-            <a:noFill/>
-          </a:ln>
-          <a:effectLst/>
-        </p:spPr>
-        <p:style>
-          <a:lnRef idx="1">
-            <a:schemeClr val="accent1"/>
-          </a:lnRef>
-          <a:fillRef idx="3">
-            <a:schemeClr val="accent1"/>
-          </a:fillRef>
-          <a:effectRef idx="2">
-            <a:schemeClr val="accent1"/>
-          </a:effectRef>
-          <a:fontRef idx="minor">
-            <a:schemeClr val="lt1"/>
-          </a:fontRef>
-        </p:style>
-        <p:txBody>
-          <a:bodyPr rtlCol="0" anchor="ctr" wrap="square"/>
-          <a:lstStyle/>
-          <a:p>
-            <a:pPr algn="ctr"/>
-          </a:p>
-        </p:txBody>
-      </p:sp>
-      <p:sp>
-        <p:nvSpPr>
-          <p:cNvPr id="10" name="TextBox 9"/>
-          <p:cNvSpPr txBox="1"/>
-          <p:nvPr/>
-        </p:nvSpPr>
-        <p:spPr>
-          <a:xfrm>
-            <a:off x="530352" y="1956816"/>
-            <a:ext cx="2645587" cy="168656"/>
-          </a:xfrm>
-          <a:prstGeom prst="rect">
-            <a:avLst/>
-          </a:prstGeom>
-          <a:noFill/>
-        </p:spPr>
-        <p:txBody>
-          <a:bodyPr wrap="square" anchor="t" lIns="0" rIns="0" tIns="0" bIns="0">
-            <a:spAutoFit/>
-          </a:bodyPr>
-          <a:lstStyle/>
-          <a:p>
-            <a:pPr algn="ctr"/>
-            <a:r>
-              <a:rPr sz="800" b="1" i="0" spc="250">
-                <a:solidFill>
-                  <a:srgbClr val="5B3FD6"/>
-                </a:solidFill>
-                <a:latin typeface="Calibri"/>
-              </a:rPr>
-              <a:t>ITEMS 1 AND 2</a:t>
-            </a:r>
-          </a:p>
-        </p:txBody>
-      </p:sp>
-      <p:sp>
-        <p:nvSpPr>
-          <p:cNvPr id="11" name="Oval 10"/>
-          <p:cNvSpPr/>
-          <p:nvPr/>
-        </p:nvSpPr>
-        <p:spPr>
-          <a:xfrm>
-            <a:off x="1752561" y="2432304"/>
-            <a:ext cx="201168" cy="201168"/>
-          </a:xfrm>
-          <a:prstGeom prst="ellipse">
-            <a:avLst/>
-          </a:prstGeom>
-          <a:solidFill>
-            <a:srgbClr val="5B3FD6"/>
-          </a:solidFill>
-          <a:ln>
-            <a:noFill/>
-          </a:ln>
-          <a:effectLst/>
-        </p:spPr>
-        <p:style>
-          <a:lnRef idx="1">
-            <a:schemeClr val="accent1"/>
-          </a:lnRef>
-          <a:fillRef idx="3">
-            <a:schemeClr val="accent1"/>
-          </a:fillRef>
-          <a:effectRef idx="2">
-            <a:schemeClr val="accent1"/>
-          </a:effectRef>
-          <a:fontRef idx="minor">
-            <a:schemeClr val="lt1"/>
-          </a:fontRef>
-        </p:style>
-        <p:txBody>
-          <a:bodyPr rtlCol="0" anchor="ctr" wrap="square"/>
-          <a:lstStyle/>
-          <a:p>
-            <a:pPr algn="ctr"/>
-          </a:p>
-        </p:txBody>
-      </p:sp>
-      <p:sp>
-        <p:nvSpPr>
-          <p:cNvPr id="12" name="Rounded Rectangle 11"/>
-          <p:cNvSpPr/>
-          <p:nvPr/>
-        </p:nvSpPr>
-        <p:spPr>
-          <a:xfrm>
-            <a:off x="530352" y="2843784"/>
-            <a:ext cx="2645587" cy="1076960"/>
-          </a:xfrm>
-          <a:prstGeom prst="roundRect">
-            <a:avLst>
-              <a:gd name="adj" fmla="val 5000"/>
-            </a:avLst>
-          </a:prstGeom>
-          <a:solidFill>
-            <a:srgbClr val="FFFFFF"/>
-          </a:solidFill>
-          <a:ln w="9525">
-            <a:solidFill>
-              <a:srgbClr val="E4E1F1"/>
-            </a:solidFill>
-          </a:ln>
-          <a:effectLst>
-            <a:outerShdw blurRad="76200" dist="19050" dir="5400000" algn="bl" rotWithShape="0">
-              <a:srgbClr val="1A0F5C">
-                <a:alpha val="12000"/>
-              </a:srgbClr>
-            </a:outerShdw>
-          </a:effectLst>
-        </p:spPr>
-        <p:style>
-          <a:lnRef idx="1">
-            <a:schemeClr val="accent1"/>
-          </a:lnRef>
-          <a:fillRef idx="3">
-            <a:schemeClr val="accent1"/>
-          </a:fillRef>
-          <a:effectRef idx="2">
-            <a:schemeClr val="accent1"/>
-          </a:effectRef>
-          <a:fontRef idx="minor">
-            <a:schemeClr val="lt1"/>
-          </a:fontRef>
-        </p:style>
-        <p:txBody>
-          <a:bodyPr rtlCol="0" anchor="ctr" wrap="square"/>
-          <a:lstStyle/>
-          <a:p>
-            <a:pPr algn="ctr"/>
-          </a:p>
-        </p:txBody>
-      </p:sp>
-      <p:sp>
-        <p:nvSpPr>
-          <p:cNvPr id="13" name="TextBox 12"/>
-          <p:cNvSpPr txBox="1"/>
-          <p:nvPr/>
-        </p:nvSpPr>
-        <p:spPr>
-          <a:xfrm>
-            <a:off x="694944" y="2990088"/>
-            <a:ext cx="2316403" cy="251205"/>
-          </a:xfrm>
-          <a:prstGeom prst="rect">
-            <a:avLst/>
-          </a:prstGeom>
-          <a:noFill/>
-        </p:spPr>
-        <p:txBody>
-          <a:bodyPr wrap="square" anchor="t" lIns="0" rIns="0" tIns="0" bIns="0">
-            <a:spAutoFit/>
-          </a:bodyPr>
-          <a:lstStyle/>
-          <a:p>
-            <a:pPr algn="l"/>
-            <a:r>
-              <a:rPr sz="1300" b="1" i="0">
-                <a:solidFill>
-                  <a:srgbClr val="1A0F5C"/>
-                </a:solidFill>
-                <a:latin typeface="Calibri"/>
-              </a:rPr>
-              <a:t>The three counts</a:t>
-            </a:r>
-          </a:p>
-        </p:txBody>
-      </p:sp>
-      <p:sp>
-        <p:nvSpPr>
-          <p:cNvPr id="14" name="TextBox 13"/>
-          <p:cNvSpPr txBox="1"/>
-          <p:nvPr/>
-        </p:nvSpPr>
-        <p:spPr>
-          <a:xfrm>
-            <a:off x="694944" y="3277870"/>
-            <a:ext cx="2316403" cy="366776"/>
-          </a:xfrm>
-          <a:prstGeom prst="rect">
-            <a:avLst/>
-          </a:prstGeom>
-          <a:noFill/>
-        </p:spPr>
-        <p:txBody>
-          <a:bodyPr wrap="square" anchor="t" lIns="0" rIns="0" tIns="0" bIns="0">
-            <a:spAutoFit/>
-          </a:bodyPr>
-          <a:lstStyle/>
-          <a:p>
-            <a:pPr algn="l"/>
-            <a:r>
-              <a:rPr sz="1000" b="0" i="0">
-                <a:solidFill>
-                  <a:srgbClr val="6B6690"/>
-                </a:solidFill>
-                <a:latin typeface="Calibri"/>
-              </a:rPr>
-              <a:t>Match each count to its question; compute lift from three counts.</a:t>
-            </a:r>
-          </a:p>
-        </p:txBody>
-      </p:sp>
-      <p:sp>
-        <p:nvSpPr>
-          <p:cNvPr id="15" name="TextBox 14"/>
-          <p:cNvSpPr txBox="1"/>
-          <p:nvPr/>
-        </p:nvSpPr>
-        <p:spPr>
-          <a:xfrm>
-            <a:off x="3358819" y="1956816"/>
-            <a:ext cx="2645587" cy="168656"/>
-          </a:xfrm>
-          <a:prstGeom prst="rect">
-            <a:avLst/>
-          </a:prstGeom>
-          <a:noFill/>
-        </p:spPr>
-        <p:txBody>
-          <a:bodyPr wrap="square" anchor="t" lIns="0" rIns="0" tIns="0" bIns="0">
-            <a:spAutoFit/>
-          </a:bodyPr>
-          <a:lstStyle/>
-          <a:p>
-            <a:pPr algn="ctr"/>
-            <a:r>
-              <a:rPr sz="800" b="1" i="0" spc="250">
-                <a:solidFill>
-                  <a:srgbClr val="5B3FD6"/>
-                </a:solidFill>
-                <a:latin typeface="Calibri"/>
-              </a:rPr>
-              <a:t>ITEMS 3 AND 7</a:t>
-            </a:r>
-          </a:p>
-        </p:txBody>
-      </p:sp>
-      <p:sp>
-        <p:nvSpPr>
-          <p:cNvPr id="16" name="Oval 15"/>
-          <p:cNvSpPr/>
-          <p:nvPr/>
-        </p:nvSpPr>
-        <p:spPr>
-          <a:xfrm>
-            <a:off x="4581029" y="2432304"/>
-            <a:ext cx="201168" cy="201168"/>
-          </a:xfrm>
-          <a:prstGeom prst="ellipse">
-            <a:avLst/>
-          </a:prstGeom>
-          <a:solidFill>
-            <a:srgbClr val="5B3FD6"/>
-          </a:solidFill>
-          <a:ln>
-            <a:noFill/>
-          </a:ln>
-          <a:effectLst/>
-        </p:spPr>
-        <p:style>
-          <a:lnRef idx="1">
-            <a:schemeClr val="accent1"/>
-          </a:lnRef>
-          <a:fillRef idx="3">
-            <a:schemeClr val="accent1"/>
-          </a:fillRef>
-          <a:effectRef idx="2">
-            <a:schemeClr val="accent1"/>
-          </a:effectRef>
-          <a:fontRef idx="minor">
-            <a:schemeClr val="lt1"/>
-          </a:fontRef>
-        </p:style>
-        <p:txBody>
-          <a:bodyPr rtlCol="0" anchor="ctr" wrap="square"/>
-          <a:lstStyle/>
-          <a:p>
-            <a:pPr algn="ctr"/>
-          </a:p>
-        </p:txBody>
-      </p:sp>
-      <p:sp>
-        <p:nvSpPr>
-          <p:cNvPr id="17" name="Rounded Rectangle 16"/>
-          <p:cNvSpPr/>
-          <p:nvPr/>
-        </p:nvSpPr>
-        <p:spPr>
-          <a:xfrm>
-            <a:off x="3358819" y="2843784"/>
-            <a:ext cx="2645587" cy="1076960"/>
-          </a:xfrm>
-          <a:prstGeom prst="roundRect">
-            <a:avLst>
-              <a:gd name="adj" fmla="val 5000"/>
-            </a:avLst>
-          </a:prstGeom>
-          <a:solidFill>
-            <a:srgbClr val="FFFFFF"/>
-          </a:solidFill>
-          <a:ln w="9525">
-            <a:solidFill>
-              <a:srgbClr val="E4E1F1"/>
-            </a:solidFill>
-          </a:ln>
-          <a:effectLst>
-            <a:outerShdw blurRad="76200" dist="19050" dir="5400000" algn="bl" rotWithShape="0">
-              <a:srgbClr val="1A0F5C">
-                <a:alpha val="12000"/>
-              </a:srgbClr>
-            </a:outerShdw>
-          </a:effectLst>
-        </p:spPr>
-        <p:style>
-          <a:lnRef idx="1">
-            <a:schemeClr val="accent1"/>
-          </a:lnRef>
-          <a:fillRef idx="3">
-            <a:schemeClr val="accent1"/>
-          </a:fillRef>
-          <a:effectRef idx="2">
-            <a:schemeClr val="accent1"/>
-          </a:effectRef>
-          <a:fontRef idx="minor">
-            <a:schemeClr val="lt1"/>
-          </a:fontRef>
-        </p:style>
-        <p:txBody>
-          <a:bodyPr rtlCol="0" anchor="ctr" wrap="square"/>
-          <a:lstStyle/>
-          <a:p>
-            <a:pPr algn="ctr"/>
-          </a:p>
-        </p:txBody>
-      </p:sp>
-      <p:sp>
-        <p:nvSpPr>
-          <p:cNvPr id="18" name="TextBox 17"/>
-          <p:cNvSpPr txBox="1"/>
-          <p:nvPr/>
-        </p:nvSpPr>
-        <p:spPr>
-          <a:xfrm>
-            <a:off x="3523411" y="2990088"/>
-            <a:ext cx="2316403" cy="251205"/>
-          </a:xfrm>
-          <a:prstGeom prst="rect">
-            <a:avLst/>
-          </a:prstGeom>
-          <a:noFill/>
-        </p:spPr>
-        <p:txBody>
-          <a:bodyPr wrap="square" anchor="t" lIns="0" rIns="0" tIns="0" bIns="0">
-            <a:spAutoFit/>
-          </a:bodyPr>
-          <a:lstStyle/>
-          <a:p>
-            <a:pPr algn="l"/>
-            <a:r>
-              <a:rPr sz="1300" b="1" i="0">
-                <a:solidFill>
-                  <a:srgbClr val="1A0F5C"/>
-                </a:solidFill>
-                <a:latin typeface="Calibri"/>
-              </a:rPr>
-              <a:t>Lift near one</a:t>
-            </a:r>
-          </a:p>
-        </p:txBody>
-      </p:sp>
-      <p:sp>
-        <p:nvSpPr>
-          <p:cNvPr id="19" name="TextBox 18"/>
-          <p:cNvSpPr txBox="1"/>
-          <p:nvPr/>
-        </p:nvSpPr>
-        <p:spPr>
-          <a:xfrm>
-            <a:off x="3523411" y="3277870"/>
-            <a:ext cx="2316403" cy="366776"/>
-          </a:xfrm>
-          <a:prstGeom prst="rect">
-            <a:avLst/>
-          </a:prstGeom>
-          <a:noFill/>
-        </p:spPr>
-        <p:txBody>
-          <a:bodyPr wrap="square" anchor="t" lIns="0" rIns="0" tIns="0" bIns="0">
-            <a:spAutoFit/>
-          </a:bodyPr>
-          <a:lstStyle/>
-          <a:p>
-            <a:pPr algn="l"/>
-            <a:r>
-              <a:rPr sz="1000" b="0" i="0">
-                <a:solidFill>
-                  <a:srgbClr val="6B6690"/>
-                </a:solidFill>
-                <a:latin typeface="Calibri"/>
-              </a:rPr>
-              <a:t>A popular partner read right; the strip's blended click-through.</a:t>
-            </a:r>
-          </a:p>
-        </p:txBody>
-      </p:sp>
-      <p:sp>
-        <p:nvSpPr>
-          <p:cNvPr id="20" name="TextBox 19"/>
-          <p:cNvSpPr txBox="1"/>
-          <p:nvPr/>
-        </p:nvSpPr>
-        <p:spPr>
-          <a:xfrm>
-            <a:off x="6187287" y="1956816"/>
-            <a:ext cx="2645587" cy="168656"/>
-          </a:xfrm>
-          <a:prstGeom prst="rect">
-            <a:avLst/>
-          </a:prstGeom>
-          <a:noFill/>
-        </p:spPr>
-        <p:txBody>
-          <a:bodyPr wrap="square" anchor="t" lIns="0" rIns="0" tIns="0" bIns="0">
-            <a:spAutoFit/>
-          </a:bodyPr>
-          <a:lstStyle/>
-          <a:p>
-            <a:pPr algn="ctr"/>
-            <a:r>
-              <a:rPr sz="800" b="1" i="0" spc="250">
-                <a:solidFill>
-                  <a:srgbClr val="5B3FD6"/>
-                </a:solidFill>
-                <a:latin typeface="Calibri"/>
-              </a:rPr>
-              <a:t>ITEMS 4, 5 AND 8</a:t>
-            </a:r>
-          </a:p>
-        </p:txBody>
-      </p:sp>
-      <p:sp>
-        <p:nvSpPr>
-          <p:cNvPr id="21" name="Oval 20"/>
-          <p:cNvSpPr/>
-          <p:nvPr/>
-        </p:nvSpPr>
-        <p:spPr>
-          <a:xfrm>
-            <a:off x="7409497" y="2432304"/>
-            <a:ext cx="201168" cy="201168"/>
-          </a:xfrm>
-          <a:prstGeom prst="ellipse">
-            <a:avLst/>
-          </a:prstGeom>
-          <a:solidFill>
-            <a:srgbClr val="5B3FD6"/>
-          </a:solidFill>
-          <a:ln>
-            <a:noFill/>
-          </a:ln>
-          <a:effectLst/>
-        </p:spPr>
-        <p:style>
-          <a:lnRef idx="1">
-            <a:schemeClr val="accent1"/>
-          </a:lnRef>
-          <a:fillRef idx="3">
-            <a:schemeClr val="accent1"/>
-          </a:fillRef>
-          <a:effectRef idx="2">
-            <a:schemeClr val="accent1"/>
-          </a:effectRef>
-          <a:fontRef idx="minor">
-            <a:schemeClr val="lt1"/>
-          </a:fontRef>
-        </p:style>
-        <p:txBody>
-          <a:bodyPr rtlCol="0" anchor="ctr" wrap="square"/>
-          <a:lstStyle/>
-          <a:p>
-            <a:pPr algn="ctr"/>
-          </a:p>
-        </p:txBody>
-      </p:sp>
-      <p:sp>
-        <p:nvSpPr>
-          <p:cNvPr id="22" name="Rounded Rectangle 21"/>
-          <p:cNvSpPr/>
-          <p:nvPr/>
-        </p:nvSpPr>
-        <p:spPr>
-          <a:xfrm>
-            <a:off x="6187287" y="2843784"/>
-            <a:ext cx="2645587" cy="1076960"/>
-          </a:xfrm>
-          <a:prstGeom prst="roundRect">
-            <a:avLst>
-              <a:gd name="adj" fmla="val 5000"/>
-            </a:avLst>
-          </a:prstGeom>
-          <a:solidFill>
-            <a:srgbClr val="FFFFFF"/>
-          </a:solidFill>
-          <a:ln w="9525">
-            <a:solidFill>
-              <a:srgbClr val="E4E1F1"/>
-            </a:solidFill>
-          </a:ln>
-          <a:effectLst>
-            <a:outerShdw blurRad="76200" dist="19050" dir="5400000" algn="bl" rotWithShape="0">
-              <a:srgbClr val="1A0F5C">
-                <a:alpha val="12000"/>
-              </a:srgbClr>
-            </a:outerShdw>
-          </a:effectLst>
-        </p:spPr>
-        <p:style>
-          <a:lnRef idx="1">
-            <a:schemeClr val="accent1"/>
-          </a:lnRef>
-          <a:fillRef idx="3">
-            <a:schemeClr val="accent1"/>
-          </a:fillRef>
-          <a:effectRef idx="2">
-            <a:schemeClr val="accent1"/>
-          </a:effectRef>
-          <a:fontRef idx="minor">
-            <a:schemeClr val="lt1"/>
-          </a:fontRef>
-        </p:style>
-        <p:txBody>
-          <a:bodyPr rtlCol="0" anchor="ctr" wrap="square"/>
-          <a:lstStyle/>
-          <a:p>
-            <a:pPr algn="ctr"/>
-          </a:p>
-        </p:txBody>
-      </p:sp>
-      <p:sp>
-        <p:nvSpPr>
-          <p:cNvPr id="23" name="TextBox 22"/>
-          <p:cNvSpPr txBox="1"/>
-          <p:nvPr/>
-        </p:nvSpPr>
-        <p:spPr>
-          <a:xfrm>
-            <a:off x="6351879" y="2990088"/>
-            <a:ext cx="2316403" cy="465836"/>
-          </a:xfrm>
-          <a:prstGeom prst="rect">
-            <a:avLst/>
-          </a:prstGeom>
-          <a:noFill/>
-        </p:spPr>
-        <p:txBody>
-          <a:bodyPr wrap="square" anchor="t" lIns="0" rIns="0" tIns="0" bIns="0">
-            <a:spAutoFit/>
-          </a:bodyPr>
-          <a:lstStyle/>
-          <a:p>
-            <a:pPr algn="l"/>
-            <a:r>
-              <a:rPr sz="1300" b="1" i="0">
-                <a:solidFill>
-                  <a:srgbClr val="1A0F5C"/>
-                </a:solidFill>
-                <a:latin typeface="Calibri"/>
-              </a:rPr>
-              <a:t>The floor, the rupee and the pairs</a:t>
-            </a:r>
-          </a:p>
-        </p:txBody>
-      </p:sp>
-      <p:sp>
-        <p:nvSpPr>
-          <p:cNvPr id="24" name="TextBox 23"/>
-          <p:cNvSpPr txBox="1"/>
-          <p:nvPr/>
-        </p:nvSpPr>
-        <p:spPr>
-          <a:xfrm>
-            <a:off x="6351879" y="3492500"/>
-            <a:ext cx="2316403" cy="366776"/>
-          </a:xfrm>
-          <a:prstGeom prst="rect">
-            <a:avLst/>
-          </a:prstGeom>
-          <a:noFill/>
-        </p:spPr>
-        <p:txBody>
-          <a:bodyPr wrap="square" anchor="t" lIns="0" rIns="0" tIns="0" bIns="0">
-            <a:spAutoFit/>
-          </a:bodyPr>
-          <a:lstStyle/>
-          <a:p>
-            <a:pPr algn="l"/>
-            <a:r>
-              <a:rPr sz="1000" b="0" i="0">
-                <a:solidFill>
-                  <a:srgbClr val="6B6690"/>
-                </a:solidFill>
-                <a:latin typeface="Calibri"/>
-              </a:rPr>
-              <a:t>A strong thin pair; what a promotion is worth; one cart's pairs.</a:t>
-            </a:r>
-          </a:p>
-        </p:txBody>
-      </p:sp>
-      <p:sp>
-        <p:nvSpPr>
-          <p:cNvPr id="25" name="TextBox 24"/>
-          <p:cNvSpPr txBox="1"/>
-          <p:nvPr/>
-        </p:nvSpPr>
-        <p:spPr>
-          <a:xfrm>
-            <a:off x="9015755" y="1956816"/>
-            <a:ext cx="2645587" cy="168656"/>
-          </a:xfrm>
-          <a:prstGeom prst="rect">
-            <a:avLst/>
-          </a:prstGeom>
-          <a:noFill/>
-        </p:spPr>
-        <p:txBody>
-          <a:bodyPr wrap="square" anchor="t" lIns="0" rIns="0" tIns="0" bIns="0">
-            <a:spAutoFit/>
-          </a:bodyPr>
-          <a:lstStyle/>
-          <a:p>
-            <a:pPr algn="ctr"/>
-            <a:r>
-              <a:rPr sz="800" b="1" i="0" spc="250">
-                <a:solidFill>
-                  <a:srgbClr val="5B3FD6"/>
-                </a:solidFill>
-                <a:latin typeface="Calibri"/>
-              </a:rPr>
-              <a:t>ITEM 6</a:t>
-            </a:r>
-          </a:p>
-        </p:txBody>
-      </p:sp>
-      <p:sp>
-        <p:nvSpPr>
-          <p:cNvPr id="26" name="Oval 25"/>
-          <p:cNvSpPr/>
-          <p:nvPr/>
-        </p:nvSpPr>
-        <p:spPr>
-          <a:xfrm>
-            <a:off x="10237965" y="2432304"/>
-            <a:ext cx="201168" cy="201168"/>
-          </a:xfrm>
-          <a:prstGeom prst="ellipse">
-            <a:avLst/>
-          </a:prstGeom>
-          <a:solidFill>
-            <a:srgbClr val="5B3FD6"/>
-          </a:solidFill>
-          <a:ln>
-            <a:noFill/>
-          </a:ln>
-          <a:effectLst/>
-        </p:spPr>
-        <p:style>
-          <a:lnRef idx="1">
-            <a:schemeClr val="accent1"/>
-          </a:lnRef>
-          <a:fillRef idx="3">
-            <a:schemeClr val="accent1"/>
-          </a:fillRef>
-          <a:effectRef idx="2">
-            <a:schemeClr val="accent1"/>
-          </a:effectRef>
-          <a:fontRef idx="minor">
-            <a:schemeClr val="lt1"/>
-          </a:fontRef>
-        </p:style>
-        <p:txBody>
-          <a:bodyPr rtlCol="0" anchor="ctr" wrap="square"/>
-          <a:lstStyle/>
-          <a:p>
-            <a:pPr algn="ctr"/>
-          </a:p>
-        </p:txBody>
-      </p:sp>
-      <p:sp>
-        <p:nvSpPr>
-          <p:cNvPr id="27" name="Rounded Rectangle 26"/>
-          <p:cNvSpPr/>
-          <p:nvPr/>
-        </p:nvSpPr>
-        <p:spPr>
-          <a:xfrm>
-            <a:off x="9015755" y="2843784"/>
-            <a:ext cx="2645587" cy="1076960"/>
-          </a:xfrm>
-          <a:prstGeom prst="roundRect">
-            <a:avLst>
-              <a:gd name="adj" fmla="val 5000"/>
-            </a:avLst>
-          </a:prstGeom>
-          <a:solidFill>
-            <a:srgbClr val="FFFFFF"/>
-          </a:solidFill>
-          <a:ln w="9525">
-            <a:solidFill>
-              <a:srgbClr val="E4E1F1"/>
-            </a:solidFill>
-          </a:ln>
-          <a:effectLst>
-            <a:outerShdw blurRad="76200" dist="19050" dir="5400000" algn="bl" rotWithShape="0">
-              <a:srgbClr val="1A0F5C">
-                <a:alpha val="12000"/>
-              </a:srgbClr>
-            </a:outerShdw>
-          </a:effectLst>
-        </p:spPr>
-        <p:style>
-          <a:lnRef idx="1">
-            <a:schemeClr val="accent1"/>
-          </a:lnRef>
-          <a:fillRef idx="3">
-            <a:schemeClr val="accent1"/>
-          </a:fillRef>
-          <a:effectRef idx="2">
-            <a:schemeClr val="accent1"/>
-          </a:effectRef>
-          <a:fontRef idx="minor">
-            <a:schemeClr val="lt1"/>
-          </a:fontRef>
-        </p:style>
-        <p:txBody>
-          <a:bodyPr rtlCol="0" anchor="ctr" wrap="square"/>
-          <a:lstStyle/>
-          <a:p>
-            <a:pPr algn="ctr"/>
-          </a:p>
-        </p:txBody>
-      </p:sp>
-      <p:sp>
-        <p:nvSpPr>
-          <p:cNvPr id="28" name="TextBox 27"/>
-          <p:cNvSpPr txBox="1"/>
-          <p:nvPr/>
-        </p:nvSpPr>
-        <p:spPr>
-          <a:xfrm>
-            <a:off x="9180347" y="2990088"/>
-            <a:ext cx="2316403" cy="251205"/>
-          </a:xfrm>
-          <a:prstGeom prst="rect">
-            <a:avLst/>
-          </a:prstGeom>
-          <a:noFill/>
-        </p:spPr>
-        <p:txBody>
-          <a:bodyPr wrap="square" anchor="t" lIns="0" rIns="0" tIns="0" bIns="0">
-            <a:spAutoFit/>
-          </a:bodyPr>
-          <a:lstStyle/>
-          <a:p>
-            <a:pPr algn="l"/>
-            <a:r>
-              <a:rPr sz="1300" b="1" i="0">
-                <a:solidFill>
-                  <a:srgbClr val="1A0F5C"/>
-                </a:solidFill>
-                <a:latin typeface="Calibri"/>
-              </a:rPr>
-              <a:t>Tuesday's return question</a:t>
-            </a:r>
-          </a:p>
-        </p:txBody>
-      </p:sp>
-      <p:sp>
-        <p:nvSpPr>
-          <p:cNvPr id="29" name="TextBox 28"/>
-          <p:cNvSpPr txBox="1"/>
-          <p:nvPr/>
-        </p:nvSpPr>
-        <p:spPr>
-          <a:xfrm>
-            <a:off x="9180347" y="3277870"/>
-            <a:ext cx="2316403" cy="366776"/>
-          </a:xfrm>
-          <a:prstGeom prst="rect">
-            <a:avLst/>
-          </a:prstGeom>
-          <a:noFill/>
-        </p:spPr>
-        <p:txBody>
-          <a:bodyPr wrap="square" anchor="t" lIns="0" rIns="0" tIns="0" bIns="0">
-            <a:spAutoFit/>
-          </a:bodyPr>
-          <a:lstStyle/>
-          <a:p>
-            <a:pPr algn="l"/>
-            <a:r>
-              <a:rPr sz="1000" b="0" i="0">
-                <a:solidFill>
-                  <a:srgbClr val="6B6690"/>
-                </a:solidFill>
-                <a:latin typeface="Calibri"/>
-              </a:rPr>
-              <a:t>The four moves of an answer to an objection that is partly right.</a:t>
-            </a:r>
-          </a:p>
-        </p:txBody>
-      </p:sp>
-      <p:sp>
-        <p:nvSpPr>
-          <p:cNvPr id="30" name="Oval 29"/>
-          <p:cNvSpPr/>
-          <p:nvPr/>
-        </p:nvSpPr>
-        <p:spPr>
-          <a:xfrm>
-            <a:off x="530352" y="6492240"/>
-            <a:ext cx="64008" cy="64008"/>
-          </a:xfrm>
-          <a:prstGeom prst="ellipse">
-            <a:avLst/>
-          </a:prstGeom>
-          <a:solidFill>
-            <a:srgbClr val="CFC9EE"/>
-          </a:solidFill>
-          <a:ln>
-            <a:noFill/>
-          </a:ln>
-          <a:effectLst/>
-        </p:spPr>
-        <p:style>
-          <a:lnRef idx="1">
-            <a:schemeClr val="accent1"/>
-          </a:lnRef>
-          <a:fillRef idx="3">
-            <a:schemeClr val="accent1"/>
-          </a:fillRef>
-          <a:effectRef idx="2">
-            <a:schemeClr val="accent1"/>
-          </a:effectRef>
-          <a:fontRef idx="minor">
-            <a:schemeClr val="lt1"/>
-          </a:fontRef>
-        </p:style>
-        <p:txBody>
-          <a:bodyPr rtlCol="0" anchor="ctr" wrap="square"/>
-          <a:lstStyle/>
-          <a:p>
-            <a:pPr algn="ctr"/>
-          </a:p>
-        </p:txBody>
-      </p:sp>
-      <p:sp>
-        <p:nvSpPr>
-          <p:cNvPr id="31" name="TextBox 30"/>
-          <p:cNvSpPr txBox="1"/>
-          <p:nvPr/>
-        </p:nvSpPr>
-        <p:spPr>
-          <a:xfrm>
-            <a:off x="640080" y="6437376"/>
-            <a:ext cx="1286446" cy="152146"/>
-          </a:xfrm>
-          <a:prstGeom prst="rect">
-            <a:avLst/>
-          </a:prstGeom>
-          <a:noFill/>
-        </p:spPr>
-        <p:txBody>
-          <a:bodyPr wrap="square" anchor="t" lIns="0" rIns="0" tIns="0" bIns="0">
-            <a:spAutoFit/>
-          </a:bodyPr>
-          <a:lstStyle/>
-          <a:p>
-            <a:pPr algn="l"/>
-            <a:r>
-              <a:rPr sz="700" b="0" i="0">
-                <a:solidFill>
-                  <a:srgbClr val="6B6690"/>
-                </a:solidFill>
-                <a:latin typeface="Calibri"/>
-              </a:rPr>
-              <a:t>What is a combo worth?</a:t>
-            </a:r>
-          </a:p>
-        </p:txBody>
-      </p:sp>
-      <p:sp>
-        <p:nvSpPr>
-          <p:cNvPr id="32" name="Oval 31"/>
-          <p:cNvSpPr/>
-          <p:nvPr/>
-        </p:nvSpPr>
-        <p:spPr>
-          <a:xfrm>
-            <a:off x="2017966" y="6492240"/>
-            <a:ext cx="64008" cy="64008"/>
-          </a:xfrm>
-          <a:prstGeom prst="ellipse">
-            <a:avLst/>
-          </a:prstGeom>
-          <a:solidFill>
-            <a:srgbClr val="5B3FD6"/>
-          </a:solidFill>
-          <a:ln>
-            <a:noFill/>
-          </a:ln>
-          <a:effectLst/>
-        </p:spPr>
-        <p:style>
-          <a:lnRef idx="1">
-            <a:schemeClr val="accent1"/>
-          </a:lnRef>
-          <a:fillRef idx="3">
-            <a:schemeClr val="accent1"/>
-          </a:fillRef>
-          <a:effectRef idx="2">
-            <a:schemeClr val="accent1"/>
-          </a:effectRef>
-          <a:fontRef idx="minor">
-            <a:schemeClr val="lt1"/>
-          </a:fontRef>
-        </p:style>
-        <p:txBody>
-          <a:bodyPr rtlCol="0" anchor="ctr" wrap="square"/>
-          <a:lstStyle/>
-          <a:p>
-            <a:pPr algn="ctr"/>
-          </a:p>
-        </p:txBody>
-      </p:sp>
-      <p:sp>
-        <p:nvSpPr>
-          <p:cNvPr id="33" name="TextBox 32"/>
-          <p:cNvSpPr txBox="1"/>
-          <p:nvPr/>
-        </p:nvSpPr>
-        <p:spPr>
-          <a:xfrm>
-            <a:off x="2127694" y="6437376"/>
-            <a:ext cx="1240440" cy="152146"/>
-          </a:xfrm>
-          <a:prstGeom prst="rect">
-            <a:avLst/>
-          </a:prstGeom>
-          <a:noFill/>
-        </p:spPr>
-        <p:txBody>
-          <a:bodyPr wrap="square" anchor="t" lIns="0" rIns="0" tIns="0" bIns="0">
-            <a:spAutoFit/>
-          </a:bodyPr>
-          <a:lstStyle/>
-          <a:p>
-            <a:pPr algn="l"/>
-            <a:r>
-              <a:rPr sz="700" b="1" i="0">
-                <a:solidFill>
-                  <a:srgbClr val="5B3FD6"/>
-                </a:solidFill>
-                <a:latin typeface="Calibri"/>
-              </a:rPr>
-              <a:t>What is a slot worth?</a:t>
-            </a:r>
-          </a:p>
-        </p:txBody>
-      </p:sp>
-      <p:sp>
-        <p:nvSpPr>
-          <p:cNvPr id="34" name="TextBox 33"/>
-          <p:cNvSpPr txBox="1"/>
-          <p:nvPr/>
-        </p:nvSpPr>
-        <p:spPr>
-          <a:xfrm>
-            <a:off x="10198303" y="6437376"/>
-            <a:ext cx="1463040" cy="160401"/>
-          </a:xfrm>
-          <a:prstGeom prst="rect">
-            <a:avLst/>
-          </a:prstGeom>
-          <a:noFill/>
-        </p:spPr>
-        <p:txBody>
-          <a:bodyPr wrap="square" anchor="t" lIns="0" rIns="0" tIns="0" bIns="0">
-            <a:spAutoFit/>
-          </a:bodyPr>
-          <a:lstStyle/>
-          <a:p>
-            <a:pPr algn="r"/>
-            <a:r>
-              <a:rPr sz="750" b="0" i="0">
-                <a:solidFill>
-                  <a:srgbClr val="6B6690"/>
-                </a:solidFill>
-                <a:latin typeface="Calibri"/>
-              </a:rPr>
-              <a:t>S74  ·  21 / 22</a:t>
-            </a:r>
-          </a:p>
-        </p:txBody>
-      </p:sp>
-    </p:spTree>
-  </p:cSld>
-  <p:clrMapOvr>
-    <a:masterClrMapping/>
-  </p:clrMapOvr>
-</p:sld>
-</file>
-
-<file path=ppt/slides/slide22.xml><?xml version="1.0" encoding="utf-8"?>
-<p:sld xmlns:a="http://schemas.openxmlformats.org/drawingml/2006/main" xmlns:p="http://schemas.openxmlformats.org/presentationml/2006/main" xmlns:r="http://schemas.openxmlformats.org/officeDocument/2006/relationships">
-  <p:cSld>
-    <p:spTree>
-      <p:nvGrpSpPr>
-        <p:cNvPr id="1" name=""/>
-        <p:cNvGrpSpPr/>
-        <p:nvPr/>
-      </p:nvGrpSpPr>
-      <p:grpSpPr/>
-      <p:pic>
-        <p:nvPicPr>
-          <p:cNvPr id="2" name="Picture 1" descr="bg_light.jpg"/>
-          <p:cNvPicPr>
-            <a:picLocks noChangeAspect="1"/>
-          </p:cNvPicPr>
-          <p:nvPr/>
-        </p:nvPicPr>
-        <p:blipFill>
-          <a:blip r:embed="rId2"/>
-          <a:stretch>
-            <a:fillRect/>
-          </a:stretch>
-        </p:blipFill>
-        <p:spPr>
-          <a:xfrm>
-            <a:off x="0" y="0"/>
-            <a:ext cx="12191695" cy="6858000"/>
-          </a:xfrm>
-          <a:prstGeom prst="rect">
-            <a:avLst/>
-          </a:prstGeom>
-        </p:spPr>
-      </p:pic>
-      <p:pic>
-        <p:nvPicPr>
-          <p:cNvPr id="3" name="Picture 2" descr="iitgn_logo.png"/>
-          <p:cNvPicPr>
-            <a:picLocks noChangeAspect="1"/>
-          </p:cNvPicPr>
-          <p:nvPr/>
-        </p:nvPicPr>
-        <p:blipFill>
-          <a:blip r:embed="rId3"/>
-          <a:stretch>
-            <a:fillRect/>
-          </a:stretch>
-        </p:blipFill>
-        <p:spPr>
-          <a:xfrm>
-            <a:off x="530352" y="201168"/>
-            <a:ext cx="420624" cy="420624"/>
-          </a:xfrm>
-          <a:prstGeom prst="rect">
-            <a:avLst/>
-          </a:prstGeom>
-        </p:spPr>
-      </p:pic>
-      <p:sp>
-        <p:nvSpPr>
-          <p:cNvPr id="4" name="TextBox 3"/>
-          <p:cNvSpPr txBox="1"/>
-          <p:nvPr/>
-        </p:nvSpPr>
-        <p:spPr>
-          <a:xfrm>
-            <a:off x="1042416" y="228600"/>
-            <a:ext cx="5120640" cy="185166"/>
-          </a:xfrm>
-          <a:prstGeom prst="rect">
-            <a:avLst/>
-          </a:prstGeom>
-          <a:noFill/>
-        </p:spPr>
-        <p:txBody>
-          <a:bodyPr wrap="square" anchor="t" lIns="0" rIns="0" tIns="0" bIns="0">
-            <a:spAutoFit/>
-          </a:bodyPr>
-          <a:lstStyle/>
-          <a:p>
-            <a:pPr algn="l"/>
-            <a:r>
-              <a:rPr sz="900" b="1" i="0">
-                <a:solidFill>
-                  <a:srgbClr val="1A0F5C"/>
-                </a:solidFill>
-                <a:latin typeface="Calibri"/>
-              </a:rPr>
-              <a:t>Indian Institute of Technology Gandhinagar</a:t>
-            </a:r>
-          </a:p>
-        </p:txBody>
-      </p:sp>
-      <p:sp>
-        <p:nvSpPr>
-          <p:cNvPr id="5" name="TextBox 4"/>
-          <p:cNvSpPr txBox="1"/>
-          <p:nvPr/>
-        </p:nvSpPr>
-        <p:spPr>
-          <a:xfrm>
-            <a:off x="1042416" y="420623"/>
-            <a:ext cx="5852160" cy="127381"/>
-          </a:xfrm>
-          <a:prstGeom prst="rect">
-            <a:avLst/>
-          </a:prstGeom>
-          <a:noFill/>
-        </p:spPr>
-        <p:txBody>
-          <a:bodyPr wrap="square" anchor="t" lIns="0" rIns="0" tIns="0" bIns="0">
-            <a:spAutoFit/>
-          </a:bodyPr>
-          <a:lstStyle/>
-          <a:p>
-            <a:pPr algn="l"/>
-            <a:r>
-              <a:rPr sz="550" b="1" i="0" spc="300">
-                <a:solidFill>
-                  <a:srgbClr val="6B6690"/>
-                </a:solidFill>
-                <a:latin typeface="Calibri"/>
-              </a:rPr>
-              <a:t>ADMINISTERED THROUGH THE COMPETENCY ADVANCEMENT ACADEMY</a:t>
-            </a:r>
-          </a:p>
-        </p:txBody>
-      </p:sp>
-      <p:sp>
-        <p:nvSpPr>
-          <p:cNvPr id="6" name="TextBox 5"/>
-          <p:cNvSpPr txBox="1"/>
-          <p:nvPr/>
-        </p:nvSpPr>
-        <p:spPr>
-          <a:xfrm>
-            <a:off x="5992063" y="310896"/>
-            <a:ext cx="5669280" cy="127381"/>
-          </a:xfrm>
-          <a:prstGeom prst="rect">
-            <a:avLst/>
-          </a:prstGeom>
-          <a:noFill/>
-        </p:spPr>
-        <p:txBody>
-          <a:bodyPr wrap="square" anchor="t" lIns="0" rIns="0" tIns="0" bIns="0">
-            <a:spAutoFit/>
-          </a:bodyPr>
-          <a:lstStyle/>
-          <a:p>
-            <a:pPr algn="r"/>
-            <a:r>
-              <a:rPr sz="550" b="1" i="0" spc="300">
-                <a:solidFill>
-                  <a:srgbClr val="6B6690"/>
-                </a:solidFill>
-                <a:latin typeface="Calibri"/>
-              </a:rPr>
-              <a:t>WEEK 4  ·  WEDNESDAY  ·  MARKET BASKET, LIFT AND CROSS-SELL</a:t>
-            </a:r>
-          </a:p>
-        </p:txBody>
-      </p:sp>
-      <p:sp>
-        <p:nvSpPr>
-          <p:cNvPr id="7" name="TextBox 6"/>
-          <p:cNvSpPr txBox="1"/>
-          <p:nvPr/>
-        </p:nvSpPr>
-        <p:spPr>
-          <a:xfrm>
-            <a:off x="530352" y="676656"/>
-            <a:ext cx="11130991" cy="512064"/>
-          </a:xfrm>
-          <a:prstGeom prst="rect">
-            <a:avLst/>
-          </a:prstGeom>
-          <a:noFill/>
-        </p:spPr>
-        <p:txBody>
-          <a:bodyPr wrap="square" anchor="b" lIns="0" rIns="0" tIns="0" bIns="0">
-            <a:spAutoFit/>
-          </a:bodyPr>
-          <a:lstStyle/>
-          <a:p>
-            <a:pPr algn="l"/>
-            <a:r>
-              <a:rPr sz="2600" b="0" i="0">
-                <a:solidFill>
-                  <a:srgbClr val="1A0F5C"/>
-                </a:solidFill>
-                <a:latin typeface="Georgia"/>
-              </a:rPr>
-              <a:t>The sentence for Friday, and Thursday's question</a:t>
-            </a:r>
-          </a:p>
-        </p:txBody>
-      </p:sp>
-      <p:sp>
-        <p:nvSpPr>
-          <p:cNvPr id="8" name="TextBox 7"/>
-          <p:cNvSpPr txBox="1"/>
-          <p:nvPr/>
-        </p:nvSpPr>
-        <p:spPr>
-          <a:xfrm>
-            <a:off x="530352" y="1243584"/>
-            <a:ext cx="11130991" cy="234696"/>
-          </a:xfrm>
-          <a:prstGeom prst="rect">
-            <a:avLst/>
-          </a:prstGeom>
-          <a:noFill/>
-        </p:spPr>
-        <p:txBody>
-          <a:bodyPr wrap="square" anchor="t" lIns="0" rIns="0" tIns="0" bIns="0">
-            <a:spAutoFit/>
-          </a:bodyPr>
-          <a:lstStyle/>
-          <a:p>
-            <a:pPr algn="l"/>
-            <a:r>
-              <a:rPr sz="1200" b="0" i="0">
-                <a:solidFill>
-                  <a:srgbClr val="6B6690"/>
-                </a:solidFill>
-                <a:latin typeface="Calibri"/>
-              </a:rPr>
               <a:t>What does the room say on Friday, and what comes next?</a:t>
             </a:r>
           </a:p>
@@ -18251,7 +17034,7 @@
         <p:spPr>
           <a:xfrm>
             <a:off x="530352" y="1956816"/>
-            <a:ext cx="11130991" cy="1074420"/>
+            <a:ext cx="11130991" cy="1341120"/>
           </a:xfrm>
           <a:prstGeom prst="roundRect">
             <a:avLst>
@@ -18299,7 +17082,7 @@
         <p:spPr>
           <a:xfrm>
             <a:off x="676656" y="2084832"/>
-            <a:ext cx="45720" cy="818388"/>
+            <a:ext cx="45720" cy="1085088"/>
           </a:xfrm>
           <a:prstGeom prst="roundRect">
             <a:avLst>
@@ -18345,7 +17128,7 @@
         <p:spPr>
           <a:xfrm>
             <a:off x="877824" y="2075688"/>
-            <a:ext cx="10564063" cy="891540"/>
+            <a:ext cx="10564063" cy="1158240"/>
           </a:xfrm>
           <a:prstGeom prst="rect">
             <a:avLst/>
@@ -18374,7 +17157,7 @@
                 </a:solidFill>
                 <a:latin typeface="Calibri"/>
               </a:rPr>
-              <a:t>"The click-through fell because the strip gave half its slots to milk, which shoppers buy anyway; ranked by lift above a 1 percent floor, the strip shows chips with cold drink, coriander with green chillies and bread with butter, and recovers about Rs 6.3 lakh a month."</a:t>
+              <a:t>"The click-through fell because the strip gave half its slots to milk, which shoppers buy anyway. Taking milk out, which ranking by lift above a 1 percent floor and a 1.5 bar does by arithmetic, recovers about Rs 6.3 lakh a month before the adds that would have come anyway; a test against a count ranking without milk shows whether lift earns more."</a:t>
             </a:r>
           </a:p>
         </p:txBody>
@@ -18387,7 +17170,7 @@
         </p:nvSpPr>
         <p:spPr>
           <a:xfrm>
-            <a:off x="530352" y="3195828"/>
+            <a:off x="530352" y="3462528"/>
             <a:ext cx="11130991" cy="807720"/>
           </a:xfrm>
           <a:prstGeom prst="roundRect">
@@ -18435,7 +17218,7 @@
         </p:nvSpPr>
         <p:spPr>
           <a:xfrm>
-            <a:off x="676656" y="3323844"/>
+            <a:off x="676656" y="3590544"/>
             <a:ext cx="45720" cy="551688"/>
           </a:xfrm>
           <a:prstGeom prst="roundRect">
@@ -18481,7 +17264,7 @@
         </p:nvSpPr>
         <p:spPr>
           <a:xfrm>
-            <a:off x="877824" y="3314700"/>
+            <a:off x="877824" y="3581400"/>
             <a:ext cx="10564063" cy="624840"/>
           </a:xfrm>
           <a:prstGeom prst="rect">
@@ -18532,7 +17315,7 @@
         </p:blipFill>
         <p:spPr>
           <a:xfrm>
-            <a:off x="530352" y="4168139"/>
+            <a:off x="530352" y="4434840"/>
             <a:ext cx="11130991" cy="1331913"/>
           </a:xfrm>
           <a:prstGeom prst="rect">
@@ -18728,7 +17511,7 @@
                 </a:solidFill>
                 <a:latin typeface="Calibri"/>
               </a:rPr>
-              <a:t>S75  ·  22 / 22</a:t>
+              <a:t>S74  ·  21 / 21</a:t>
             </a:r>
           </a:p>
         </p:txBody>
@@ -18984,7 +17767,7 @@
         </p:nvGraphicFramePr>
         <p:xfrm>
           <a:off x="530352" y="1956816"/>
-          <a:ext cx="11130991" cy="2218944"/>
+          <a:ext cx="11130990" cy="2588768"/>
         </p:xfrm>
         <a:graphic>
           <a:graphicData uri="http://schemas.openxmlformats.org/drawingml/2006/table">
@@ -18993,8 +17776,8 @@
                 <a:tableStyleId>{2D5ABB26-0587-4C30-8999-92F81FD0307C}</a:tableStyleId>
               </a:tblPr>
               <a:tblGrid>
-                <a:gridCol w="7351928"/>
-                <a:gridCol w="3779063"/>
+                <a:gridCol w="7543831"/>
+                <a:gridCol w="3587159"/>
               </a:tblGrid>
               <a:tr h="369824">
                 <a:tc>
@@ -19147,7 +17930,7 @@
                           </a:solidFill>
                           <a:latin typeface="Calibri"/>
                         </a:rPr>
-                        <a:t>The card's discount, on every bill holding both</a:t>
+                        <a:t>Rusk's margin, what the shop keeps: price less cost</a:t>
                       </a:r>
                     </a:p>
                   </a:txBody>
@@ -19169,7 +17952,7 @@
                           </a:solidFill>
                           <a:latin typeface="Calibri"/>
                         </a:rPr>
-                        <a:t>Rs 1</a:t>
+                        <a:t>Rs 12</a:t>
                       </a:r>
                     </a:p>
                   </a:txBody>
@@ -19193,7 +17976,7 @@
                           </a:solidFill>
                           <a:latin typeface="Calibri"/>
                         </a:rPr>
-                        <a:t>Printing the cards</a:t>
+                        <a:t>The card's discount, on every bill holding both</a:t>
                       </a:r>
                     </a:p>
                   </a:txBody>
@@ -19215,7 +17998,7 @@
                           </a:solidFill>
                           <a:latin typeface="Calibri"/>
                         </a:rPr>
-                        <a:t>Rs 20</a:t>
+                        <a:t>Rs 1</a:t>
                       </a:r>
                     </a:p>
                   </a:txBody>
@@ -19239,7 +18022,7 @@
                           </a:solidFill>
                           <a:latin typeface="Calibri"/>
                         </a:rPr>
-                        <a:t>Tea bills without rusk that add a pack, assumed</a:t>
+                        <a:t>Printing the cards</a:t>
                       </a:r>
                     </a:p>
                   </a:txBody>
@@ -19261,7 +18044,7 @@
                           </a:solidFill>
                           <a:latin typeface="Calibri"/>
                         </a:rPr>
-                        <a:t>4 percent, range 2 to 6</a:t>
+                        <a:t>Rs 20</a:t>
                       </a:r>
                     </a:p>
                   </a:txBody>
@@ -19272,6 +18055,52 @@
                   </a:tcPr>
                 </a:tc>
               </a:tr>
+              <a:tr h="369824">
+                <a:tc>
+                  <a:txBody>
+                    <a:bodyPr/>
+                    <a:lstStyle/>
+                    <a:p>
+                      <a:r>
+                        <a:rPr sz="1400" b="0" i="0">
+                          <a:solidFill>
+                            <a:srgbClr val="1A1440"/>
+                          </a:solidFill>
+                          <a:latin typeface="Calibri"/>
+                        </a:rPr>
+                        <a:t>Tea bills without rusk that add a pack, assumed</a:t>
+                      </a:r>
+                    </a:p>
+                  </a:txBody>
+                  <a:tcPr marL="101600" marR="101600" marT="38100" marB="38100" anchor="ctr">
+                    <a:solidFill>
+                      <a:srgbClr val="F4F2FA"/>
+                    </a:solidFill>
+                  </a:tcPr>
+                </a:tc>
+                <a:tc>
+                  <a:txBody>
+                    <a:bodyPr/>
+                    <a:lstStyle/>
+                    <a:p>
+                      <a:r>
+                        <a:rPr sz="1400" b="0" i="0">
+                          <a:solidFill>
+                            <a:srgbClr val="1A1440"/>
+                          </a:solidFill>
+                          <a:latin typeface="Calibri"/>
+                        </a:rPr>
+                        <a:t>4 percent, range 2 to 6</a:t>
+                      </a:r>
+                    </a:p>
+                  </a:txBody>
+                  <a:tcPr marL="101600" marR="101600" marT="38100" marB="38100" anchor="ctr">
+                    <a:solidFill>
+                      <a:srgbClr val="F4F2FA"/>
+                    </a:solidFill>
+                  </a:tcPr>
+                </a:tc>
+              </a:tr>
             </a:tbl>
           </a:graphicData>
         </a:graphic>
@@ -19284,7 +18113,7 @@
         </p:nvSpPr>
         <p:spPr>
           <a:xfrm>
-            <a:off x="530352" y="4431792"/>
+            <a:off x="530352" y="4801616"/>
             <a:ext cx="11130991" cy="1048512"/>
           </a:xfrm>
           <a:prstGeom prst="rect">
@@ -19503,7 +18332,7 @@
                 </a:solidFill>
                 <a:latin typeface="Calibri"/>
               </a:rPr>
-              <a:t>S57  ·  3 / 22</a:t>
+              <a:t>S57  ·  3 / 21</a:t>
             </a:r>
           </a:p>
         </p:txBody>
@@ -19837,7 +18666,7 @@
                 </a:solidFill>
                 <a:latin typeface="Calibri"/>
               </a:rPr>
-              <a:t>Only the 450 tea bills without rusk can change: 4 percent of them, 18 bills, add a pack, and 18 x Rs 12 is Rs 216 of margin. The card hands Rs 1 back on all 168 bills that hold both, the 150 that held both anyway and the 18 new ones, and the cards cost Rs 20, so Rs 216 less Rs 168 less Rs 20 leaves Rs 28. Option a books rusk sales on all 168 bills, Rs 5,040, which is 180 times the gain.</a:t>
+              <a:t>The card is assumed to change only the 450 tea bills without rusk: 4 percent of them, 18 bills, add a pack, and 18 x Rs 12 is Rs 216 of margin. The card hands Rs 1 back on all 168 bills that hold both, the 150 that held both anyway and the 18 new ones, and the cards cost Rs 20, so Rs 216 less Rs 168 less Rs 20 leaves Rs 28. Option a books rusk sales on all 168 bills, Rs 5,040, which is 180 times the gain.</a:t>
             </a:r>
           </a:p>
         </p:txBody>
@@ -20030,7 +18859,7 @@
                 </a:solidFill>
                 <a:latin typeface="Calibri"/>
               </a:rPr>
-              <a:t>S58  ·  4 / 22</a:t>
+              <a:t>S58  ·  4 / 21</a:t>
             </a:r>
           </a:p>
         </p:txBody>
@@ -20236,7 +19065,7 @@
                 </a:solidFill>
                 <a:latin typeface="Georgia"/>
               </a:rPr>
-              <a:t>Rs 2 off loses Rs 140; the response sets the sign</a:t>
+              <a:t>At the same 4 percent, Rs 2 off loses Rs 140</a:t>
             </a:r>
           </a:p>
         </p:txBody>
@@ -20888,7 +19717,7 @@
                 </a:solidFill>
                 <a:latin typeface="Calibri"/>
               </a:rPr>
-              <a:t>S59  ·  5 / 22</a:t>
+              <a:t>S59  ·  5 / 21</a:t>
             </a:r>
           </a:p>
         </p:txBody>
@@ -21143,7 +19972,7 @@
         <p:spPr>
           <a:xfrm>
             <a:off x="530352" y="1645920"/>
-            <a:ext cx="502920" cy="300735"/>
+            <a:ext cx="502920" cy="267716"/>
           </a:xfrm>
           <a:prstGeom prst="rect">
             <a:avLst/>
@@ -21158,7 +19987,7 @@
           <a:p>
             <a:pPr algn="l"/>
             <a:r>
-              <a:rPr sz="1600" b="0" i="0">
+              <a:rPr sz="1400" b="0" i="0">
                 <a:solidFill>
                   <a:srgbClr val="5B3FD6"/>
                 </a:solidFill>
@@ -21178,21 +20007,21 @@
         <p:spPr>
           <a:xfrm>
             <a:off x="1097280" y="1682496"/>
-            <a:ext cx="10564063" cy="334264"/>
-          </a:xfrm>
-          <a:prstGeom prst="rect">
-            <a:avLst/>
-          </a:prstGeom>
-          <a:noFill/>
-        </p:spPr>
-        <p:txBody>
-          <a:bodyPr wrap="square" anchor="t" lIns="0" rIns="0" tIns="0" bIns="0">
-            <a:spAutoFit/>
-          </a:bodyPr>
-          <a:lstStyle/>
-          <a:p>
-            <a:r>
-              <a:rPr sz="1300" b="0" i="0">
+            <a:ext cx="10564063" cy="299720"/>
+          </a:xfrm>
+          <a:prstGeom prst="rect">
+            <a:avLst/>
+          </a:prstGeom>
+          <a:noFill/>
+        </p:spPr>
+        <p:txBody>
+          <a:bodyPr wrap="square" anchor="t" lIns="0" rIns="0" tIns="0" bIns="0">
+            <a:spAutoFit/>
+          </a:bodyPr>
+          <a:lstStyle/>
+          <a:p>
+            <a:r>
+              <a:rPr sz="1100" b="0" i="0">
                 <a:solidFill>
                   <a:srgbClr val="1A1440"/>
                 </a:solidFill>
@@ -21211,8 +20040,8 @@
         </p:nvSpPr>
         <p:spPr>
           <a:xfrm>
-            <a:off x="530352" y="2053336"/>
-            <a:ext cx="502920" cy="300735"/>
+            <a:off x="530352" y="2018792"/>
+            <a:ext cx="502920" cy="267716"/>
           </a:xfrm>
           <a:prstGeom prst="rect">
             <a:avLst/>
@@ -21227,7 +20056,7 @@
           <a:p>
             <a:pPr algn="l"/>
             <a:r>
-              <a:rPr sz="1600" b="0" i="0">
+              <a:rPr sz="1400" b="0" i="0">
                 <a:solidFill>
                   <a:srgbClr val="5B3FD6"/>
                 </a:solidFill>
@@ -21246,22 +20075,22 @@
         </p:nvSpPr>
         <p:spPr>
           <a:xfrm>
-            <a:off x="1097280" y="2089912"/>
-            <a:ext cx="10564063" cy="334264"/>
-          </a:xfrm>
-          <a:prstGeom prst="rect">
-            <a:avLst/>
-          </a:prstGeom>
-          <a:noFill/>
-        </p:spPr>
-        <p:txBody>
-          <a:bodyPr wrap="square" anchor="t" lIns="0" rIns="0" tIns="0" bIns="0">
-            <a:spAutoFit/>
-          </a:bodyPr>
-          <a:lstStyle/>
-          <a:p>
-            <a:r>
-              <a:rPr sz="1300" b="0" i="0">
+            <a:off x="1097280" y="2055368"/>
+            <a:ext cx="10564063" cy="299720"/>
+          </a:xfrm>
+          <a:prstGeom prst="rect">
+            <a:avLst/>
+          </a:prstGeom>
+          <a:noFill/>
+        </p:spPr>
+        <p:txBody>
+          <a:bodyPr wrap="square" anchor="t" lIns="0" rIns="0" tIns="0" bIns="0">
+            <a:spAutoFit/>
+          </a:bodyPr>
+          <a:lstStyle/>
+          <a:p>
+            <a:r>
+              <a:rPr sz="1100" b="0" i="0">
                 <a:solidFill>
                   <a:srgbClr val="1A1440"/>
                 </a:solidFill>
@@ -21280,8 +20109,8 @@
         </p:nvSpPr>
         <p:spPr>
           <a:xfrm>
-            <a:off x="530352" y="2460752"/>
-            <a:ext cx="502920" cy="300735"/>
+            <a:off x="530352" y="2391664"/>
+            <a:ext cx="502920" cy="267716"/>
           </a:xfrm>
           <a:prstGeom prst="rect">
             <a:avLst/>
@@ -21296,7 +20125,7 @@
           <a:p>
             <a:pPr algn="l"/>
             <a:r>
-              <a:rPr sz="1600" b="0" i="0">
+              <a:rPr sz="1400" b="0" i="0">
                 <a:solidFill>
                   <a:srgbClr val="5B3FD6"/>
                 </a:solidFill>
@@ -21315,22 +20144,22 @@
         </p:nvSpPr>
         <p:spPr>
           <a:xfrm>
-            <a:off x="1097280" y="2497328"/>
-            <a:ext cx="10564063" cy="334264"/>
-          </a:xfrm>
-          <a:prstGeom prst="rect">
-            <a:avLst/>
-          </a:prstGeom>
-          <a:noFill/>
-        </p:spPr>
-        <p:txBody>
-          <a:bodyPr wrap="square" anchor="t" lIns="0" rIns="0" tIns="0" bIns="0">
-            <a:spAutoFit/>
-          </a:bodyPr>
-          <a:lstStyle/>
-          <a:p>
-            <a:r>
-              <a:rPr sz="1300" b="0" i="0">
+            <a:off x="1097280" y="2428240"/>
+            <a:ext cx="10564063" cy="299720"/>
+          </a:xfrm>
+          <a:prstGeom prst="rect">
+            <a:avLst/>
+          </a:prstGeom>
+          <a:noFill/>
+        </p:spPr>
+        <p:txBody>
+          <a:bodyPr wrap="square" anchor="t" lIns="0" rIns="0" tIns="0" bIns="0">
+            <a:spAutoFit/>
+          </a:bodyPr>
+          <a:lstStyle/>
+          <a:p>
+            <a:r>
+              <a:rPr sz="1100" b="0" i="0">
                 <a:solidFill>
                   <a:srgbClr val="1A1440"/>
                 </a:solidFill>
@@ -21349,8 +20178,8 @@
         </p:nvSpPr>
         <p:spPr>
           <a:xfrm>
-            <a:off x="530352" y="2868168"/>
-            <a:ext cx="502920" cy="300735"/>
+            <a:off x="530352" y="2764536"/>
+            <a:ext cx="502920" cy="267716"/>
           </a:xfrm>
           <a:prstGeom prst="rect">
             <a:avLst/>
@@ -21365,7 +20194,7 @@
           <a:p>
             <a:pPr algn="l"/>
             <a:r>
-              <a:rPr sz="1600" b="0" i="0">
+              <a:rPr sz="1400" b="0" i="0">
                 <a:solidFill>
                   <a:srgbClr val="5B3FD6"/>
                 </a:solidFill>
@@ -21384,22 +20213,22 @@
         </p:nvSpPr>
         <p:spPr>
           <a:xfrm>
-            <a:off x="1097280" y="2904744"/>
-            <a:ext cx="10564063" cy="334264"/>
-          </a:xfrm>
-          <a:prstGeom prst="rect">
-            <a:avLst/>
-          </a:prstGeom>
-          <a:noFill/>
-        </p:spPr>
-        <p:txBody>
-          <a:bodyPr wrap="square" anchor="t" lIns="0" rIns="0" tIns="0" bIns="0">
-            <a:spAutoFit/>
-          </a:bodyPr>
-          <a:lstStyle/>
-          <a:p>
-            <a:r>
-              <a:rPr sz="1300" b="0" i="0">
+            <a:off x="1097280" y="2801112"/>
+            <a:ext cx="10564063" cy="299720"/>
+          </a:xfrm>
+          <a:prstGeom prst="rect">
+            <a:avLst/>
+          </a:prstGeom>
+          <a:noFill/>
+        </p:spPr>
+        <p:txBody>
+          <a:bodyPr wrap="square" anchor="t" lIns="0" rIns="0" tIns="0" bIns="0">
+            <a:spAutoFit/>
+          </a:bodyPr>
+          <a:lstStyle/>
+          <a:p>
+            <a:r>
+              <a:rPr sz="1100" b="0" i="0">
                 <a:solidFill>
                   <a:srgbClr val="1A1440"/>
                 </a:solidFill>
@@ -21418,8 +20247,8 @@
         </p:nvSpPr>
         <p:spPr>
           <a:xfrm>
-            <a:off x="530352" y="3421888"/>
-            <a:ext cx="11130991" cy="1052576"/>
+            <a:off x="530352" y="3283712"/>
+            <a:ext cx="11130991" cy="983488"/>
           </a:xfrm>
           <a:prstGeom prst="roundRect">
             <a:avLst>
@@ -21472,7 +20301,7 @@
         </p:nvSpPr>
         <p:spPr>
           <a:xfrm>
-            <a:off x="758952" y="3719576"/>
+            <a:off x="758952" y="3546856"/>
             <a:ext cx="457200" cy="457200"/>
           </a:xfrm>
           <a:prstGeom prst="ellipse">
@@ -21524,7 +20353,7 @@
         </p:blipFill>
         <p:spPr>
           <a:xfrm>
-            <a:off x="868680" y="3829304"/>
+            <a:off x="868680" y="3656584"/>
             <a:ext cx="237744" cy="237744"/>
           </a:xfrm>
           <a:prstGeom prst="rect">
@@ -21540,7 +20369,7 @@
         </p:nvSpPr>
         <p:spPr>
           <a:xfrm>
-            <a:off x="1399031" y="3568192"/>
+            <a:off x="1399031" y="3430016"/>
             <a:ext cx="9987991" cy="160401"/>
           </a:xfrm>
           <a:prstGeom prst="rect">
@@ -21575,35 +20404,35 @@
         </p:nvSpPr>
         <p:spPr>
           <a:xfrm>
-            <a:off x="1399031" y="3787648"/>
-            <a:ext cx="9987991" cy="613664"/>
-          </a:xfrm>
-          <a:prstGeom prst="rect">
-            <a:avLst/>
-          </a:prstGeom>
-          <a:noFill/>
-        </p:spPr>
-        <p:txBody>
-          <a:bodyPr wrap="square" anchor="t" lIns="0" rIns="0" tIns="0" bIns="0">
-            <a:spAutoFit/>
-          </a:bodyPr>
-          <a:lstStyle/>
-          <a:p>
-            <a:r>
-              <a:rPr sz="1300" b="0" i="0">
+            <a:off x="1399031" y="3649472"/>
+            <a:ext cx="9987991" cy="544576"/>
+          </a:xfrm>
+          <a:prstGeom prst="rect">
+            <a:avLst/>
+          </a:prstGeom>
+          <a:noFill/>
+        </p:spPr>
+        <p:txBody>
+          <a:bodyPr wrap="square" anchor="t" lIns="0" rIns="0" tIns="0" bIns="0">
+            <a:spAutoFit/>
+          </a:bodyPr>
+          <a:lstStyle/>
+          <a:p>
+            <a:r>
+              <a:rPr sz="1100" b="0" i="0">
                 <a:solidFill>
                   <a:srgbClr val="1A1440"/>
                 </a:solidFill>
                 <a:latin typeface="Calibri"/>
               </a:rPr>
-              <a:t>[F] "A combo offer lifts the pair's sales; is it worth running?" Margin on the purchases that would not have happened, less the discount paid on all of them, less the fixed cost, said as a range.</a:t>
+              <a:t>[F] "A combo offer lifts the pair's sales; is it worth running?" Margin on the purchases the offer creates, less the discount paid on every purchase that takes it, including those that would have happened anyway, less the fixed cost, said as a range.</a:t>
             </a:r>
           </a:p>
         </p:txBody>
       </p:sp>
       <p:pic>
         <p:nvPicPr>
-          <p:cNvPr id="22" name="mermaid diagram" descr="badb4b84bcb7b044.png"/>
+          <p:cNvPr id="22" name="mermaid diagram" descr="4f662cc80396841e.png"/>
           <p:cNvPicPr>
             <a:picLocks noChangeAspect="1"/>
           </p:cNvPicPr>
@@ -21617,8 +20446,8 @@
         </p:blipFill>
         <p:spPr>
           <a:xfrm>
-            <a:off x="3236072" y="4639056"/>
-            <a:ext cx="5719549" cy="1560576"/>
+            <a:off x="2856259" y="4431792"/>
+            <a:ext cx="6479177" cy="1767839"/>
           </a:xfrm>
           <a:prstGeom prst="rect">
             <a:avLst/>
@@ -21813,7 +20642,7 @@
                 </a:solidFill>
                 <a:latin typeface="Calibri"/>
               </a:rPr>
-              <a:t>S60  ·  6 / 22</a:t>
+              <a:t>S60  ·  6 / 21</a:t>
             </a:r>
           </a:p>
         </p:txBody>
@@ -22304,7 +21133,7 @@
                 </a:solidFill>
                 <a:latin typeface="Calibri"/>
               </a:rPr>
-              <a:t>7 / 22</a:t>
+              <a:t>7 / 21</a:t>
             </a:r>
           </a:p>
         </p:txBody>
@@ -23868,7 +22697,7 @@
                 </a:solidFill>
                 <a:latin typeface="Calibri"/>
               </a:rPr>
-              <a:t>S61  ·  8 / 22</a:t>
+              <a:t>S61  ·  8 / 21</a:t>
             </a:r>
           </a:p>
         </p:txBody>
@@ -24074,7 +22903,7 @@
                 </a:solidFill>
                 <a:latin typeface="Georgia"/>
               </a:rPr>
-              <a:t>Which of these four pairs would you promote?</a:t>
+              <a:t>Which pair ranks first under the floor rule?</a:t>
             </a:r>
           </a:p>
         </p:txBody>
@@ -24109,7 +22938,7 @@
                 </a:solidFill>
                 <a:latin typeface="Calibri"/>
               </a:rPr>
-              <a:t>Each pair shows its support and its lift. Which takes the strip's first slot?</a:t>
+              <a:t>Each pair shows its support and its lift. Under a 1 percent floor and a 1.5 bar, which ranks first?</a:t>
             </a:r>
           </a:p>
         </p:txBody>
@@ -25210,7 +24039,7 @@
                 </a:solidFill>
                 <a:latin typeface="Calibri"/>
               </a:rPr>
-              <a:t>S62  ·  9 / 22</a:t>
+              <a:t>S62  ·  9 / 21</a:t>
             </a:r>
           </a:p>
         </p:txBody>

</xml_diff>